<commit_message>
Add V2X enablement analysis slide to AEB presentation
- New slide 3: V2X 赋能 C-NCAP 2027 AEB 测试场景
- Left panel: Appendix P VRU scenarios via V2P (occlusion, turning, weather)
- Right panel: Appendix Q C2C scenarios via V2V/V2I (NLOS, weather, intent sharing)
- Key stats: ~70% scenarios V2X-enhanced, V2V+P+I, NLOS, All-weather

Co-Authored-By: Claude Opus 4.7 <noreply@anthropic.com>
</commit_message>
<xml_diff>
--- a/AEB_Introduction.pptx
+++ b/AEB_Introduction.pptx
@@ -10,6 +10,7 @@
   <p:sldIdLst>
     <p:sldId id="256" r:id="rId2"/>
     <p:sldId id="257" r:id="rId3"/>
+    <p:sldId id="261" r:id="rId10"/>
   </p:sldIdLst>
   <p:sldSz cx="12192000" cy="6858000"/>
   <p:notesSz cx="6858000" cy="12192000"/>
@@ -347,6 +348,46 @@
 </p:notes>
 </file>
 
+<file path=ppt/notesSlides/notesSlide3.xml><?xml version="1.0" encoding="utf-8"?>
+<p:notesSlide xmlns:a="http://schemas.openxmlformats.org/drawingml/2006/main" xmlns:r="http://schemas.openxmlformats.org/officeDocument/2006/relationships" xmlns:p="http://schemas.openxmlformats.org/presentationml/2006/main">
+  <p:cSld>
+    <p:spTree>
+      <p:nvGrpSpPr>
+        <p:cNvPr id="1" name=""/>
+        <p:cNvGrpSpPr/>
+        <p:nvPr/>
+      </p:nvGrpSpPr>
+      <p:grpSpPr>
+        <a:xfrm>
+          <a:off x="0" y="0"/>
+          <a:ext cx="0" cy="0"/>
+          <a:chOff x="0" y="0"/>
+          <a:chExt cx="0" cy="0"/>
+        </a:xfrm>
+      </p:grpSpPr>
+      <p:sp>
+        <p:nvSpPr>
+          <p:cNvPr id="2" name="Notes Placeholder 1"/>
+          <p:cNvSpPr/>
+          <p:nvPr/>
+        </p:nvSpPr>
+        <p:spPr>
+          <a:xfrm>
+            <a:off x="0" y="0"/>
+            <a:ext cx="6858000" cy="12192000"/>
+          </a:xfrm>
+        </p:spPr>
+        <p:txBody>
+          <a:bodyPr/>
+          <a:lstStyle/>
+          <a:p/>
+        </p:txBody>
+      </p:sp>
+    </p:spTree>
+  </p:cSld>
+</p:notesSlide>
+</file>
+
 <file path=ppt/slideLayouts/slideLayout1.xml><?xml version="1.0" encoding="utf-8"?>
 <p:sldLayout xmlns:a="http://schemas.openxmlformats.org/drawingml/2006/main" xmlns:r="http://schemas.openxmlformats.org/officeDocument/2006/relationships" xmlns:p="http://schemas.openxmlformats.org/presentationml/2006/main" preserve="1">
   <p:cSld name="DEFAULT">
@@ -4358,6 +4399,162 @@
   <p:clrMapOvr>
     <a:masterClrMapping/>
   </p:clrMapOvr>
+</p:sld>
+</file>
+
+<file path=ppt/slides/slide3.xml><?xml version="1.0" encoding="UTF-8" standalone="yes"?>
+<p:sld xmlns:a="http://schemas.openxmlformats.org/drawingml/2006/main" xmlns:r="http://schemas.openxmlformats.org/officeDocument/2006/relationships" xmlns:p="http://schemas.openxmlformats.org/presentationml/2006/main">
+  <p:cSld name="Slide 3 - V2X">
+    <p:bg><p:bgPr><a:solidFill><a:srgbClr val="1D0638"/></a:solidFill><a:effectLst/></p:bgPr></p:bg>
+    <p:spTree>
+      <p:nvGrpSpPr><p:cNvPr id="1" name=""/><p:cNvGrpSpPr/><p:nvPr/></p:nvGrpSpPr>
+      <p:grpSpPr><a:xfrm><a:off x="0" y="0"/><a:ext cx="0" cy="0"/><a:chOff x="0" y="0"/><a:chExt cx="0" cy="0"/></a:xfrm></p:grpSpPr>
+      <!-- Top line -->
+      <p:sp><p:nvSpPr><p:cNvPr id="2" name="TopLine"/><p:cNvSpPr/><p:nvPr/></p:nvSpPr>
+        <p:spPr><a:xfrm><a:off x="0" y="0"/><a:ext cx="12192000" cy="54864"/></a:xfrm><a:prstGeom prst="rect"><a:avLst/></a:prstGeom><a:solidFill><a:srgbClr val="442EE0"/></a:solidFill><a:ln/></p:spPr></p:sp>
+      <!-- Left bar -->
+      <p:sp><p:nvSpPr><p:cNvPr id="3" name="LeftBar"/><p:cNvSpPr/><p:nvPr/></p:nvSpPr>
+        <p:spPr><a:xfrm><a:off x="0" y="0"/><a:ext cx="73152" cy="6858000"/></a:xfrm><a:prstGeom prst="rect"><a:avLst/></a:prstGeom><a:solidFill><a:srgbClr val="442EE0"/></a:solidFill><a:ln/></p:spPr></p:sp>
+      <!-- Green dot -->
+      <p:sp><p:nvSpPr><p:cNvPr id="4" name="GreenDot"/><p:cNvSpPr/><p:nvPr/></p:nvSpPr>
+        <p:spPr><a:xfrm><a:off x="548640" y="411480"/><a:ext cx="228600" cy="228600"/></a:xfrm><a:prstGeom prst="ellipse"><a:avLst/></a:prstGeom><a:solidFill><a:srgbClr val="1EEF97"/></a:solidFill><a:ln/></p:spPr></p:sp>
+      <!-- CARIAD label -->
+      <p:sp><p:nvSpPr><p:cNvPr id="5" name="CARIAD"/><p:cNvSpPr/><p:nvPr/></p:nvSpPr>
+        <p:spPr><a:xfrm><a:off x="868680" y="384048"/><a:ext cx="2743200" cy="320040"/></a:xfrm><a:prstGeom prst="rect"><a:avLst/></a:prstGeom><a:noFill/><a:ln/></p:spPr>
+        <p:txBody><a:bodyPr wrap="square" rtlCol="0" anchor="t"/><a:lstStyle/>
+          <a:p><a:pPr marL="0" indent="0" algn="l"><a:buNone/></a:pPr><a:r><a:rPr lang="en-US" sz="1100" dirty="0"><a:solidFill><a:srgbClr val="CDCDD2"/></a:solidFill><a:latin typeface="Arial" pitchFamily="34" charset="0"/><a:ea typeface="Arial" pitchFamily="34" charset="-122"/></a:rPr><a:t>C A R I A D</a:t></a:r></a:p></p:txBody></p:sp>
+      <!-- Title -->
+      <p:sp><p:nvSpPr><p:cNvPr id="6" name="Title"/><p:cNvSpPr/><p:nvPr/></p:nvSpPr>
+        <p:spPr><a:xfrm><a:off x="526774" y="700000"/><a:ext cx="10972800" cy="640000"/></a:xfrm><a:prstGeom prst="rect"><a:avLst/></a:prstGeom><a:noFill/><a:ln/></p:spPr>
+        <p:txBody><a:bodyPr wrap="square" rtlCol="0" anchor="t"/><a:lstStyle/>
+          <a:p><a:pPr marL="0" indent="0" algn="l"><a:buNone/></a:pPr>
+            <a:r><a:rPr lang="en-US" sz="3200" b="1" dirty="0"><a:solidFill><a:srgbClr val="FFFFFF"/></a:solidFill><a:latin typeface="Arial" pitchFamily="34" charset="0"/><a:ea typeface="Arial" pitchFamily="34" charset="-122"/></a:rPr><a:t>V2X </a:t></a:r>
+            <a:r><a:rPr lang="en-US" sz="3200" b="1" dirty="0"><a:solidFill><a:srgbClr val="1EEF97"/></a:solidFill><a:latin typeface="Arial" pitchFamily="34" charset="0"/><a:ea typeface="Arial" pitchFamily="34" charset="-122"/></a:rPr><a:t>赋能</a:t></a:r>
+            <a:r><a:rPr lang="en-US" sz="3200" b="1" dirty="0"><a:solidFill><a:srgbClr val="FFFFFF"/></a:solidFill><a:latin typeface="Arial" pitchFamily="34" charset="0"/><a:ea typeface="Arial" pitchFamily="34" charset="-122"/></a:rPr><a:t> C-NCAP 2027 AEB 测试场景</a:t></a:r>
+          </a:p></p:txBody></p:sp>
+      <!-- Underline -->
+      <p:sp><p:nvSpPr><p:cNvPr id="7" name="Underline"/><p:cNvSpPr/><p:nvPr/></p:nvSpPr>
+        <p:spPr><a:xfrm><a:off x="526774" y="1340000"/><a:ext cx="2743200" cy="45720"/></a:xfrm><a:prstGeom prst="rect"><a:avLst/></a:prstGeom><a:solidFill><a:srgbClr val="1EEF97"/></a:solidFill><a:ln/></p:spPr></p:sp>
+      <!-- Subtitle -->
+      <p:sp><p:nvSpPr><p:cNvPr id="8" name="Subtitle"/><p:cNvSpPr/><p:nvPr/></p:nvSpPr>
+        <p:spPr><a:xfrm><a:off x="526774" y="1450000"/><a:ext cx="10972800" cy="274320"/></a:xfrm><a:prstGeom prst="rect"><a:avLst/></a:prstGeom><a:noFill/><a:ln/></p:spPr>
+        <p:txBody><a:bodyPr wrap="square" rtlCol="0" anchor="t"/><a:lstStyle/>
+          <a:p><a:pPr marL="0" indent="0" algn="l"><a:buNone/></a:pPr>
+            <a:r><a:rPr lang="zh-CN" sz="1400" dirty="0"><a:solidFill><a:srgbClr val="CDCDD2"/></a:solidFill><a:latin typeface="Arial" pitchFamily="34" charset="0"/><a:ea typeface="Microsoft YaHei" pitchFamily="34" charset="-122"/></a:rPr><a:t>V2V 车车直连 | V2P 车与弱势道路使用者 | V2I 车路协同 | 非视距穿透 · 恶劣天气抗扰 · 意图共享</a:t></a:r>
+          </a:p></p:txBody></p:sp>
+      <!-- Vertical divider -->
+      <p:sp><p:nvSpPr><p:cNvPr id="9" name="VLine"/><p:cNvSpPr/><p:nvPr/></p:nvSpPr>
+        <p:spPr><a:xfrm><a:off x="6131451" y="1850000"/><a:ext cx="45719" cy="4200000"/></a:xfrm><a:prstGeom prst="rect"><a:avLst/></a:prstGeom><a:solidFill><a:srgbClr val="442EE0"/></a:solidFill><a:ln/></p:spPr></p:sp>
+      <!-- Left header -->
+      <p:sp><p:nvSpPr><p:cNvPr id="10" name="LeftHeader"/><p:cNvSpPr/><p:nvPr/></p:nvSpPr>
+        <p:spPr><a:xfrm><a:off x="526774" y="1820000"/><a:ext cx="5100000" cy="320040"/></a:xfrm><a:prstGeom prst="rect"><a:avLst/></a:prstGeom><a:noFill/><a:ln/></p:spPr>
+        <p:txBody><a:bodyPr wrap="square" rtlCol="0" anchor="t"/><a:lstStyle/>
+          <a:p><a:pPr marL="0" indent="0" algn="l"><a:buNone/></a:pPr>
+            <a:r><a:rPr lang="en-US" sz="1100" b="1" dirty="0"><a:solidFill><a:srgbClr val="1EEF97"/></a:solidFill><a:latin typeface="Arial" pitchFamily="34" charset="0"/><a:ea typeface="Arial" pitchFamily="34" charset="-122"/></a:rPr><a:t>附录P — VRU场景 | V2P / 车与弱势道路使用者</a:t></a:r>
+          </a:p></p:txBody></p:sp>
+      <!-- Left list -->
+      <p:sp><p:nvSpPr><p:cNvPr id="11" name="LeftList"/><p:cNvSpPr/><p:nvPr/></p:nvSpPr>
+        <p:spPr><a:xfrm><a:off x="526774" y="2160000"/><a:ext cx="5100000" cy="4000000"/></a:xfrm><a:prstGeom prst="rect"><a:avLst/></a:prstGeom><a:noFill/><a:ln/></p:spPr>
+        <p:txBody><a:bodyPr wrap="square" rtlCol="0" anchor="t"/><a:lstStyle/><a:p><a:pPr marL="0" indent="0" algn="l"><a:buNone/></a:pPr>
+          <a:r><a:rPr lang="zh-CN" sz="900" b="1" dirty="0"><a:solidFill><a:srgbClr val="1EEF97"/></a:solidFill><a:latin typeface="Arial" pitchFamily="34" charset="0"/><a:ea typeface="Microsoft YaHei" pitchFamily="34" charset="-122"/></a:rPr><a:t>V2P 穿透遮挡 — 行人/二轮车感知</a:t></a:r></a:p><a:p><a:pPr marL="171450" indent="0" algn="l"><a:buNone/></a:pPr>
+          <a:r><a:rPr lang="zh-CN" sz="700" dirty="0"><a:solidFill><a:srgbClr val="CDCDD2"/></a:solidFill><a:latin typeface="Arial" pitchFamily="34" charset="0"/><a:ea typeface="Microsoft YaHei" pitchFamily="34" charset="-122"/></a:rPr><a:t>CPFC-MO 动态遮挡儿童 — 被挡儿童可被V2P提前感知</a:t></a:r></a:p><a:p><a:pPr marL="171450" indent="0" algn="l"><a:buNone/></a:pPr>
+          <a:r><a:rPr lang="zh-CN" sz="700" dirty="0"><a:solidFill><a:srgbClr val="CDCDD2"/></a:solidFill><a:latin typeface="Arial" pitchFamily="34" charset="0"/><a:ea typeface="Microsoft YaHei" pitchFamily="34" charset="-122"/></a:rPr><a:t>CPNC-AI / CPFC-BI 干扰横穿 — 被遮挡弱势道路使用者</a:t></a:r></a:p><a:p><a:pPr marL="171450" indent="0" algn="l"><a:buNone/></a:pPr>
+          <a:r><a:rPr lang="zh-CN" sz="700" dirty="0"><a:solidFill><a:srgbClr val="CDCDD2"/></a:solidFill><a:latin typeface="Arial" pitchFamily="34" charset="0"/><a:ea typeface="Microsoft YaHei" pitchFamily="34" charset="-122"/></a:rPr><a:t>CBOFA / CBFA-MO 遮挡斜穿 — 穿透车辆障碍</a:t></a:r></a:p><a:p><a:pPr marL="171450" indent="0" algn="l"><a:buNone/></a:pPr>
+          <a:r><a:rPr lang="zh-CN" sz="700" dirty="0"><a:solidFill><a:srgbClr val="CDCDD2"/></a:solidFill><a:latin typeface="Arial" pitchFamily="34" charset="0"/><a:ea typeface="Microsoft YaHei" pitchFamily="34" charset="-122"/></a:rPr><a:t>CBNA-AI / CSFA-BI 干扰近端 — V2P弥补盲区</a:t></a:r></a:p><a:p><a:pPr marL="171450" indent="0" algn="l"><a:buNone/></a:pPr>
+          <a:r><a:rPr lang="zh-CN" sz="700" dirty="0"><a:solidFill><a:srgbClr val="CDCDD2"/></a:solidFill><a:latin typeface="Arial" pitchFamily="34" charset="0"/><a:ea typeface="Microsoft YaHei" pitchFamily="34" charset="-122"/></a:rPr><a:t>CSTAO-RN 右转遮挡 — 路侧V2I+车端V2P协同</a:t></a:r></a:p><a:p><a:pPr marL="0" indent="0" algn="l"><a:buNone/></a:pPr><a:endParaRPr lang="zh-CN" sz="300" dirty="0"/></a:p><a:p><a:pPr marL="0" indent="0" algn="l"><a:buNone/></a:pPr>
+          <a:r><a:rPr lang="zh-CN" sz="900" b="1" dirty="0"><a:solidFill><a:srgbClr val="1EEF97"/></a:solidFill><a:latin typeface="Arial" pitchFamily="34" charset="0"/><a:ea typeface="Microsoft YaHei" pitchFamily="34" charset="-122"/></a:rPr><a:t>V2P 转弯/横穿预警</a:t></a:r></a:p><a:p><a:pPr marL="171450" indent="0" algn="l"><a:buNone/></a:pPr>
+          <a:r><a:rPr lang="zh-CN" sz="700" dirty="0"><a:solidFill><a:srgbClr val="CDCDD2"/></a:solidFill><a:latin typeface="Arial" pitchFamily="34" charset="0"/><a:ea typeface="Microsoft YaHei" pitchFamily="34" charset="-122"/></a:rPr><a:t>CPTA-LF / CPTA-RF 转弯横穿行人 — 提前感知意图</a:t></a:r></a:p><a:p><a:pPr marL="171450" indent="0" algn="l"><a:buNone/></a:pPr>
+          <a:r><a:rPr lang="zh-CN" sz="700" dirty="0"><a:solidFill><a:srgbClr val="CDCDD2"/></a:solidFill><a:latin typeface="Arial" pitchFamily="34" charset="0"/><a:ea typeface="Microsoft YaHei" pitchFamily="34" charset="-122"/></a:rPr><a:t>C2S RCPf / C2B RCPn 转弯横穿二轮 — 路口盲区</a:t></a:r></a:p><a:p><a:pPr marL="171450" indent="0" algn="l"><a:buNone/></a:pPr>
+          <a:r><a:rPr lang="zh-CN" sz="700" dirty="0"><a:solidFill><a:srgbClr val="CDCDD2"/></a:solidFill><a:latin typeface="Arial" pitchFamily="34" charset="0"/><a:ea typeface="Microsoft YaHei" pitchFamily="34" charset="-122"/></a:rPr><a:t>CBLAt 转弯切入 / CBLAc 变道切入 — V2P/V2V共享意图</a:t></a:r></a:p><a:p><a:pPr marL="171450" indent="0" algn="l"><a:buNone/></a:pPr>
+          <a:r><a:rPr lang="zh-CN" sz="700" dirty="0"><a:solidFill><a:srgbClr val="CDCDD2"/></a:solidFill><a:latin typeface="Arial" pitchFamily="34" charset="0"/><a:ea typeface="Microsoft YaHei" pitchFamily="34" charset="-122"/></a:rPr><a:t>CSFhol 直行对向二轮 — 远距离V2P预警</a:t></a:r></a:p><a:p><a:pPr marL="0" indent="0" algn="l"><a:buNone/></a:pPr><a:endParaRPr lang="zh-CN" sz="300" dirty="0"/></a:p><a:p><a:pPr marL="0" indent="0" algn="l"><a:buNone/></a:pPr>
+          <a:r><a:rPr lang="zh-CN" sz="900" b="1" dirty="0"><a:solidFill><a:srgbClr val="442EE0"/></a:solidFill><a:latin typeface="Arial" pitchFamily="34" charset="0"/><a:ea typeface="Microsoft YaHei" pitchFamily="34" charset="-122"/></a:rPr><a:t>恶劣环境优势 — 天气/光照</a:t></a:r></a:p><a:p><a:pPr marL="171450" indent="0" algn="l"><a:buNone/></a:pPr>
+          <a:r><a:rPr lang="zh-CN" sz="700" dirty="0"><a:solidFill><a:srgbClr val="CDCDD2"/></a:solidFill><a:latin typeface="Arial" pitchFamily="34" charset="0"/><a:ea typeface="Microsoft YaHei" pitchFamily="34" charset="-122"/></a:rPr><a:t>CPFAr 雨天远端横穿 — 摄像头受限，V2X不受影响</a:t></a:r></a:p><a:p><a:pPr marL="171450" indent="0" algn="l"><a:buNone/></a:pPr>
+          <a:r><a:rPr lang="zh-CN" sz="700" dirty="0"><a:solidFill><a:srgbClr val="CDCDD2"/></a:solidFill><a:latin typeface="Arial" pitchFamily="34" charset="0"/><a:ea typeface="Microsoft YaHei" pitchFamily="34" charset="-122"/></a:rPr><a:t>CBLAb 电动自行车夜间 — 弱光下V2P优于视觉</a:t></a:r></a:p><a:p><a:pPr marL="171450" indent="0" algn="l"><a:buNone/></a:pPr>
+          <a:r><a:rPr lang="zh-CN" sz="700" dirty="0"><a:solidFill><a:srgbClr val="CDCDD2"/></a:solidFill><a:latin typeface="Arial" pitchFamily="34" charset="0"/><a:ea typeface="Microsoft YaHei" pitchFamily="34" charset="-122"/></a:rPr><a:t>CPFAh / CPLAh 高速场景 — 远距离V2P提前预警</a:t></a:r></a:p><a:p><a:pPr marL="0" indent="0" algn="l"><a:buNone/></a:pPr><a:endParaRPr lang="zh-CN" sz="300" dirty="0"/></a:p></p:txBody></p:sp>
+      <!-- Right header -->
+      <p:sp><p:nvSpPr><p:cNvPr id="20" name="RightHeader"/><p:cNvSpPr/><p:nvPr/></p:nvSpPr>
+        <p:spPr><a:xfrm><a:off x="6636028" y="1820000"/><a:ext cx="5100000" cy="320040"/></a:xfrm><a:prstGeom prst="rect"><a:avLst/></a:prstGeom><a:noFill/><a:ln/></p:spPr>
+        <p:txBody><a:bodyPr wrap="square" rtlCol="0" anchor="t"/><a:lstStyle/>
+          <a:p><a:pPr marL="0" indent="0" algn="l"><a:buNone/></a:pPr>
+            <a:r><a:rPr lang="en-US" sz="1100" b="1" dirty="0"><a:solidFill><a:srgbClr val="1EEF97"/></a:solidFill><a:latin typeface="Arial" pitchFamily="34" charset="0"/><a:ea typeface="Arial" pitchFamily="34" charset="-122"/></a:rPr><a:t>附录Q — C2C场景 | V2V / V2I 车车与车路协同</a:t></a:r>
+          </a:p></p:txBody></p:sp>
+      <!-- Right list -->
+      <p:sp><p:nvSpPr><p:cNvPr id="21" name="RightList"/><p:cNvSpPr/><p:nvPr/></p:nvSpPr>
+        <p:spPr><a:xfrm><a:off x="6636028" y="2160000"/><a:ext cx="5100000" cy="4000000"/></a:xfrm><a:prstGeom prst="rect"><a:avLst/></a:prstGeom><a:noFill/><a:ln/></p:spPr>
+        <p:txBody><a:bodyPr wrap="square" rtlCol="0" anchor="t"/><a:lstStyle/><a:p><a:pPr marL="0" indent="0" algn="l"><a:buNone/></a:pPr>
+          <a:r><a:rPr lang="zh-CN" sz="900" b="1" dirty="0"><a:solidFill><a:srgbClr val="1EEF97"/></a:solidFill><a:latin typeface="Arial" pitchFamily="34" charset="0"/><a:ea typeface="Microsoft YaHei" pitchFamily="34" charset="-122"/></a:rPr><a:t>V2V 遮挡/非视距 — 穿透障碍</a:t></a:r></a:p><a:p><a:pPr marL="171450" indent="0" algn="l"><a:buNone/></a:pPr>
+          <a:r><a:rPr lang="zh-CN" sz="700" dirty="0"><a:solidFill><a:srgbClr val="CDCDD2"/></a:solidFill><a:latin typeface="Arial" pitchFamily="34" charset="0"/><a:ea typeface="Microsoft YaHei" pitchFamily="34" charset="-122"/></a:rPr><a:t>C2C SCPmo 动态遮挡横穿 — 被挡车辆V2V预警</a:t></a:r></a:p><a:p><a:pPr marL="171450" indent="0" algn="l"><a:buNone/></a:pPr>
+          <a:r><a:rPr lang="zh-CN" sz="700" dirty="0"><a:solidFill><a:srgbClr val="CDCDD2"/></a:solidFill><a:latin typeface="Arial" pitchFamily="34" charset="0"/><a:ea typeface="Microsoft YaHei" pitchFamily="34" charset="-122"/></a:rPr><a:t>C2C SCPso 静态遮挡横穿 — 越过建筑物/车辆感知</a:t></a:r></a:p><a:p><a:pPr marL="171450" indent="0" algn="l"><a:buNone/></a:pPr>
+          <a:r><a:rPr lang="zh-CN" sz="700" dirty="0"><a:solidFill><a:srgbClr val="CDCDD2"/></a:solidFill><a:latin typeface="Arial" pitchFamily="34" charset="0"/><a:ea typeface="Microsoft YaHei" pitchFamily="34" charset="-122"/></a:rPr><a:t>CCFT / CCFTf 转弯对撞 — 路口建筑遮挡，V2V直连</a:t></a:r></a:p><a:p><a:pPr marL="171450" indent="0" algn="l"><a:buNone/></a:pPr>
+          <a:r><a:rPr lang="zh-CN" sz="700" dirty="0"><a:solidFill><a:srgbClr val="CDCDD2"/></a:solidFill><a:latin typeface="Arial" pitchFamily="34" charset="0"/><a:ea typeface="Microsoft YaHei" pitchFamily="34" charset="-122"/></a:rPr><a:t>LCPf / LCPn 左转横穿 — 对向遮挡车辆提前通信</a:t></a:r></a:p><a:p><a:pPr marL="0" indent="0" algn="l"><a:buNone/></a:pPr><a:endParaRPr lang="zh-CN" sz="300" dirty="0"/></a:p><a:p><a:pPr marL="0" indent="0" algn="l"><a:buNone/></a:pPr>
+          <a:r><a:rPr lang="zh-CN" sz="900" b="1" dirty="0"><a:solidFill><a:srgbClr val="1EEF97"/></a:solidFill><a:latin typeface="Arial" pitchFamily="34" charset="0"/><a:ea typeface="Microsoft YaHei" pitchFamily="34" charset="-122"/></a:rPr><a:t>V2V 恶劣天气 — 传感器降级</a:t></a:r></a:p><a:p><a:pPr marL="171450" indent="0" algn="l"><a:buNone/></a:pPr>
+          <a:r><a:rPr lang="zh-CN" sz="700" dirty="0"><a:solidFill><a:srgbClr val="CDCDD2"/></a:solidFill><a:latin typeface="Arial" pitchFamily="34" charset="0"/><a:ea typeface="Microsoft YaHei" pitchFamily="34" charset="-122"/></a:rPr><a:t>CCRsr 雨天追尾 — 雷达/摄像头衰减，V2V不受影响</a:t></a:r></a:p><a:p><a:pPr marL="171450" indent="0" algn="l"><a:buNone/></a:pPr>
+          <a:r><a:rPr lang="zh-CN" sz="700" dirty="0"><a:solidFill><a:srgbClr val="CDCDD2"/></a:solidFill><a:latin typeface="Arial" pitchFamily="34" charset="0"/><a:ea typeface="Microsoft YaHei" pitchFamily="34" charset="-122"/></a:rPr><a:t>CCRsf 雾天追尾 — 能见度极低，V2V稳定通信</a:t></a:r></a:p><a:p><a:pPr marL="171450" indent="0" algn="l"><a:buNone/></a:pPr>
+          <a:r><a:rPr lang="zh-CN" sz="700" dirty="0"><a:solidFill><a:srgbClr val="CDCDD2"/></a:solidFill><a:latin typeface="Arial" pitchFamily="34" charset="0"/><a:ea typeface="Microsoft YaHei" pitchFamily="34" charset="-122"/></a:rPr><a:t>CCFhos 直行对撞 — 雨雾天远距离V2V预警</a:t></a:r></a:p><a:p><a:pPr marL="0" indent="0" algn="l"><a:buNone/></a:pPr><a:endParaRPr lang="zh-CN" sz="300" dirty="0"/></a:p><a:p><a:pPr marL="0" indent="0" algn="l"><a:buNone/></a:pPr>
+          <a:r><a:rPr lang="zh-CN" sz="900" b="1" dirty="0"><a:solidFill><a:srgbClr val="442EE0"/></a:solidFill><a:latin typeface="Arial" pitchFamily="34" charset="0"/><a:ea typeface="Microsoft YaHei" pitchFamily="34" charset="-122"/></a:rPr><a:t>V2V 意图共享 — 切入/制动</a:t></a:r></a:p><a:p><a:pPr marL="171450" indent="0" algn="l"><a:buNone/></a:pPr>
+          <a:r><a:rPr lang="zh-CN" sz="700" dirty="0"><a:solidFill><a:srgbClr val="CDCDD2"/></a:solidFill><a:latin typeface="Arial" pitchFamily="34" charset="0"/><a:ea typeface="Microsoft YaHei" pitchFamily="34" charset="-122"/></a:rPr><a:t>CCRc 切入追尾 — 邻车变道意图实时共享</a:t></a:r></a:p><a:p><a:pPr marL="171450" indent="0" algn="l"><a:buNone/></a:pPr>
+          <a:r><a:rPr lang="zh-CN" sz="700" dirty="0"><a:solidFill><a:srgbClr val="CDCDD2"/></a:solidFill><a:latin typeface="Arial" pitchFamily="34" charset="0"/><a:ea typeface="Microsoft YaHei" pitchFamily="34" charset="-122"/></a:rPr><a:t>CCRb 制动追尾 — 前车制动信号低延迟广播</a:t></a:r></a:p><a:p><a:pPr marL="171450" indent="0" algn="l"><a:buNone/></a:pPr>
+          <a:r><a:rPr lang="zh-CN" sz="700" dirty="0"><a:solidFill><a:srgbClr val="CDCDD2"/></a:solidFill><a:latin typeface="Arial" pitchFamily="34" charset="0"/><a:ea typeface="Microsoft YaHei" pitchFamily="34" charset="-122"/></a:rPr><a:t>CCRh 高速追尾 — 超视距提前获知前车减速</a:t></a:r></a:p><a:p><a:pPr marL="171450" indent="0" algn="l"><a:buNone/></a:pPr>
+          <a:r><a:rPr lang="zh-CN" sz="700" dirty="0"><a:solidFill><a:srgbClr val="CDCDD2"/></a:solidFill><a:latin typeface="Arial" pitchFamily="34" charset="0"/><a:ea typeface="Microsoft YaHei" pitchFamily="34" charset="-122"/></a:rPr><a:t>CCRbc 弯道制动 — 弯道遮挡场景V2V补盲</a:t></a:r></a:p><a:p><a:pPr marL="171450" indent="0" algn="l"><a:buNone/></a:pPr>
+          <a:r><a:rPr lang="zh-CN" sz="700" dirty="0"><a:solidFill><a:srgbClr val="CDCDD2"/></a:solidFill><a:latin typeface="Arial" pitchFamily="34" charset="0"/><a:ea typeface="Microsoft YaHei" pitchFamily="34" charset="-122"/></a:rPr><a:t>RCPf 右转横穿 — 转向意图+位置共享</a:t></a:r></a:p><a:p><a:pPr marL="0" indent="0" algn="l"><a:buNone/></a:pPr><a:endParaRPr lang="zh-CN" sz="300" dirty="0"/></a:p><a:p><a:pPr marL="0" indent="0" algn="l"><a:buNone/></a:pPr>
+          <a:r><a:rPr lang="zh-CN" sz="900" b="1" dirty="0"><a:solidFill><a:srgbClr val="442EE0"/></a:solidFill><a:latin typeface="Arial" pitchFamily="34" charset="0"/><a:ea typeface="Microsoft YaHei" pitchFamily="34" charset="-122"/></a:rPr><a:t>V2I 路侧协同</a:t></a:r></a:p><a:p><a:pPr marL="171450" indent="0" algn="l"><a:buNone/></a:pPr>
+          <a:r><a:rPr lang="zh-CN" sz="700" dirty="0"><a:solidFill><a:srgbClr val="CDCDD2"/></a:solidFill><a:latin typeface="Arial" pitchFamily="34" charset="0"/><a:ea typeface="Microsoft YaHei" pitchFamily="34" charset="-122"/></a:rPr><a:t>所有十字路口转弯/横穿场景均可通过V2I路侧单元(RSU)</a:t></a:r></a:p><a:p><a:pPr marL="171450" indent="0" algn="l"><a:buNone/></a:pPr>
+          <a:r><a:rPr lang="zh-CN" sz="700" dirty="0"><a:solidFill><a:srgbClr val="CDCDD2"/></a:solidFill><a:latin typeface="Arial" pitchFamily="34" charset="0"/><a:ea typeface="Microsoft YaHei" pitchFamily="34" charset="-122"/></a:rPr><a:t>获取路口全局目标列表，弥补单车感知盲区</a:t></a:r></a:p><a:p><a:pPr marL="171450" indent="0" algn="l"><a:buNone/></a:pPr>
+          <a:r><a:rPr lang="zh-CN" sz="700" dirty="0"><a:solidFill><a:srgbClr val="CDCDD2"/></a:solidFill><a:latin typeface="Arial" pitchFamily="34" charset="0"/><a:ea typeface="Microsoft YaHei" pitchFamily="34" charset="-122"/></a:rPr><a:t>典型: CPTA系列 / CCFT系列 / C2C LCP&SCP系列</a:t></a:r></a:p><a:p><a:pPr marL="0" indent="0" algn="l"><a:buNone/></a:pPr><a:endParaRPr lang="zh-CN" sz="300" dirty="0"/></a:p></p:txBody></p:sp>
+      <!-- Bottom separator -->
+      <p:sp><p:nvSpPr><p:cNvPr id="90" name="BtmLine"/><p:cNvSpPr/><p:nvPr/></p:nvSpPr>
+        <p:spPr><a:xfrm><a:off x="526774" y="5900000"/><a:ext cx="11064240" cy="10973"/></a:xfrm><a:prstGeom prst="rect"><a:avLst/></a:prstGeom><a:solidFill><a:srgbClr val="373741"/></a:solidFill><a:ln/></p:spPr></p:sp>
+      <!-- Stats row -->
+      <p:sp><p:nvSpPr><p:cNvPr id="91" name="Stat1"/><p:cNvSpPr/><p:nvPr/></p:nvSpPr>
+        <p:spPr><a:xfrm><a:off x="526774" y="5970000"/><a:ext cx="2743200" cy="292608"/></a:xfrm><a:prstGeom prst="rect"><a:avLst/></a:prstGeom><a:noFill/><a:ln/></p:spPr>
+        <p:txBody><a:bodyPr wrap="square" rtlCol="0" anchor="t"/><a:lstStyle/>
+          <a:p><a:pPr marL="0" indent="0" algn="l"><a:buNone/></a:pPr>
+            <a:r><a:rPr lang="en-US" sz="1600" b="1" dirty="0"><a:solidFill><a:srgbClr val="1EEF97"/></a:solidFill><a:latin typeface="Arial" pitchFamily="34" charset="0"/><a:ea typeface="Arial" pitchFamily="34" charset="-122"/></a:rPr><a:t>~70%</a:t></a:r></a:p></p:txBody></p:sp>
+      <p:sp><p:nvSpPr><p:cNvPr id="92" name="Stat1Label"/><p:cNvSpPr/><p:nvPr/></p:nvSpPr>
+        <p:spPr><a:xfrm><a:off x="526774" y="6215000"/><a:ext cx="2743200" cy="182880"/></a:xfrm><a:prstGeom prst="rect"><a:avLst/></a:prstGeom><a:noFill/><a:ln/></p:spPr>
+        <p:txBody><a:bodyPr wrap="square" rtlCol="0" anchor="t"/><a:lstStyle/>
+          <a:p><a:pPr marL="0" indent="0" algn="l"><a:buNone/></a:pPr>
+            <a:r><a:rPr lang="zh-CN" sz="800" dirty="0"><a:solidFill><a:srgbClr val="CDCDD2"/></a:solidFill><a:latin typeface="Arial" pitchFamily="34" charset="0"/><a:ea typeface="Microsoft YaHei" pitchFamily="34" charset="-122"/></a:rPr><a:t>场景可由V2X增强</a:t></a:r></a:p></p:txBody></p:sp>
+      <p:sp><p:nvSpPr><p:cNvPr id="93" name="Stat2"/><p:cNvSpPr/><p:nvPr/></p:nvSpPr>
+        <p:spPr><a:xfrm><a:off x="3292834" y="5970000"/><a:ext cx="2743200" cy="292608"/></a:xfrm><a:prstGeom prst="rect"><a:avLst/></a:prstGeom><a:noFill/><a:ln/></p:spPr>
+        <p:txBody><a:bodyPr wrap="square" rtlCol="0" anchor="t"/><a:lstStyle/>
+          <a:p><a:pPr marL="0" indent="0" algn="l"><a:buNone/></a:pPr>
+            <a:r><a:rPr lang="en-US" sz="1600" b="1" dirty="0"><a:solidFill><a:srgbClr val="1EEF97"/></a:solidFill><a:latin typeface="Arial" pitchFamily="34" charset="0"/><a:ea typeface="Arial" pitchFamily="34" charset="-122"/></a:rPr><a:t>V2V+P+I</a:t></a:r></a:p></p:txBody></p:sp>
+      <p:sp><p:nvSpPr><p:cNvPr id="94" name="Stat2Label"/><p:cNvSpPr/><p:nvPr/></p:nvSpPr>
+        <p:spPr><a:xfrm><a:off x="3292834" y="6215000"/><a:ext cx="2743200" cy="182880"/></a:xfrm><a:prstGeom prst="rect"><a:avLst/></a:prstGeom><a:noFill/><a:ln/></p:spPr>
+        <p:txBody><a:bodyPr wrap="square" rtlCol="0" anchor="t"/><a:lstStyle/>
+          <a:p><a:pPr marL="0" indent="0" algn="l"><a:buNone/></a:pPr>
+            <a:r><a:rPr lang="zh-CN" sz="800" dirty="0"><a:solidFill><a:srgbClr val="CDCDD2"/></a:solidFill><a:latin typeface="Arial" pitchFamily="34" charset="0"/><a:ea typeface="Microsoft YaHei" pitchFamily="34" charset="-122"/></a:rPr><a:t>V2X通信模式协同</a:t></a:r></a:p></p:txBody></p:sp>
+      <p:sp><p:nvSpPr><p:cNvPr id="95" name="Stat3"/><p:cNvSpPr/><p:nvPr/></p:nvSpPr>
+        <p:spPr><a:xfrm><a:off x="6357863" y="5970000"/><a:ext cx="2743200" cy="292608"/></a:xfrm><a:prstGeom prst="rect"><a:avLst/></a:prstGeom><a:noFill/><a:ln/></p:spPr>
+        <p:txBody><a:bodyPr wrap="square" rtlCol="0" anchor="t"/><a:lstStyle/>
+          <a:p><a:pPr marL="0" indent="0" algn="l"><a:buNone/></a:pPr>
+            <a:r><a:rPr lang="en-US" sz="1600" b="1" dirty="0"><a:solidFill><a:srgbClr val="1EEF97"/></a:solidFill><a:latin typeface="Arial" pitchFamily="34" charset="0"/><a:ea typeface="Arial" pitchFamily="34" charset="-122"/></a:rPr><a:t>NLOS</a:t></a:r></a:p></p:txBody></p:sp>
+      <p:sp><p:nvSpPr><p:cNvPr id="96" name="Stat3Label"/><p:cNvSpPr/><p:nvPr/></p:nvSpPr>
+        <p:spPr><a:xfrm><a:off x="6357863" y="6195000"/><a:ext cx="2743200" cy="182880"/></a:xfrm><a:prstGeom prst="rect"><a:avLst/></a:prstGeom><a:noFill/><a:ln/></p:spPr>
+        <p:txBody><a:bodyPr wrap="square" rtlCol="0" anchor="t"/><a:lstStyle/>
+          <a:p><a:pPr marL="0" indent="0" algn="l"><a:buNone/></a:pPr>
+            <a:r><a:rPr lang="zh-CN" sz="800" dirty="0"><a:solidFill><a:srgbClr val="CDCDD2"/></a:solidFill><a:latin typeface="Arial" pitchFamily="34" charset="0"/><a:ea typeface="Microsoft YaHei" pitchFamily="34" charset="-122"/></a:rPr><a:t>非视距穿透是核心优势</a:t></a:r></a:p></p:txBody></p:sp>
+      <p:sp><p:nvSpPr><p:cNvPr id="97" name="Stat4"/><p:cNvSpPr/><p:nvPr/></p:nvSpPr>
+        <p:spPr><a:xfrm><a:off x="9123923" y="5970000"/><a:ext cx="2743200" cy="292608"/></a:xfrm><a:prstGeom prst="rect"><a:avLst/></a:prstGeom><a:noFill/><a:ln/></p:spPr>
+        <p:txBody><a:bodyPr wrap="square" rtlCol="0" anchor="t"/><a:lstStyle/>
+          <a:p><a:pPr marL="0" indent="0" algn="l"><a:buNone/></a:pPr>
+            <a:r><a:rPr lang="en-US" sz="1600" b="1" dirty="0"><a:solidFill><a:srgbClr val="1EEF97"/></a:solidFill><a:latin typeface="Arial" pitchFamily="34" charset="0"/><a:ea typeface="Arial" pitchFamily="34" charset="-122"/></a:rPr><a:t>全天候</a:t></a:r></a:p></p:txBody></p:sp>
+      <p:sp><p:nvSpPr><p:cNvPr id="98" name="Stat4Label"/><p:cNvSpPr/><p:nvPr/></p:nvSpPr>
+        <p:spPr><a:xfrm><a:off x="9123923" y="6195000"/><a:ext cx="2743200" cy="182880"/></a:xfrm><a:prstGeom prst="rect"><a:avLst/></a:prstGeom><a:noFill/><a:ln/></p:spPr>
+        <p:txBody><a:bodyPr wrap="square" rtlCol="0" anchor="t"/><a:lstStyle/>
+          <a:p><a:pPr marL="0" indent="0" algn="l"><a:buNone/></a:pPr>
+            <a:r><a:rPr lang="zh-CN" sz="800" dirty="0"><a:solidFill><a:srgbClr val="CDCDD2"/></a:solidFill><a:latin typeface="Arial" pitchFamily="34" charset="0"/><a:ea typeface="Microsoft YaHei" pitchFamily="34" charset="-122"/></a:rPr><a:t>雨雾夜不受影响</a:t></a:r></a:p></p:txBody></p:sp>
+      <!-- Footer -->
+      <p:sp><p:nvSpPr><p:cNvPr id="99" name="Footer"/><p:cNvSpPr/><p:nvPr/></p:nvSpPr>
+        <p:spPr><a:xfrm><a:off x="526774" y="6500000"/><a:ext cx="4572000" cy="137160"/></a:xfrm><a:prstGeom prst="rect"><a:avLst/></a:prstGeom><a:noFill/><a:ln/></p:spPr>
+        <p:txBody><a:bodyPr wrap="square" rtlCol="0" anchor="t"/><a:lstStyle/>
+          <a:p><a:pPr marL="0" indent="0" algn="l"><a:buNone/></a:pPr>
+            <a:r><a:rPr lang="zh-CN" sz="700" dirty="0"><a:solidFill><a:srgbClr val="888888"/></a:solidFill><a:latin typeface="Arial" pitchFamily="34" charset="0"/><a:ea typeface="Microsoft YaHei" pitchFamily="34" charset="-122"/></a:rPr><a:t>INTERNAL / CONFIDENTIAL  |  CSD class: 2.5  |  基于 C-NCAP 2027 场景的 V2X 赋能分析</a:t></a:r>
+          </a:p></p:txBody></p:sp>
+    </p:spTree>
+  </p:cSld>
+  <p:clrMapOvr><a:masterClrMapping/></p:clrMapOvr>
 </p:sld>
 </file>
 

</xml_diff>

<commit_message>
Fix V2X slide: use python-pptx/lxml for proper PPTX XML handling
- Replace broken add_v2x_slide.mjs with add_v2x_slide.py
- Python version correctly handles namespace (p:txBody vs a:txBody)
- Fix corrupted PPTX, restore valid 3-slide presentation
- Slide 3 has complete V2X enablement analysis
- Left: V2P VRU scenarios (occlusion, turning, weather)
- Right: V2V/V2I C2C scenarios (NLOS, weather, intent sharing, RSU)

Co-Authored-By: Claude Opus 4.7 <noreply@anthropic.com>
</commit_message>
<xml_diff>
--- a/AEB_Introduction.pptx
+++ b/AEB_Introduction.pptx
@@ -349,7 +349,7 @@
 </file>
 
 <file path=ppt/notesSlides/notesSlide3.xml><?xml version="1.0" encoding="utf-8"?>
-<p:notesSlide xmlns:a="http://schemas.openxmlformats.org/drawingml/2006/main" xmlns:r="http://schemas.openxmlformats.org/officeDocument/2006/relationships" xmlns:p="http://schemas.openxmlformats.org/presentationml/2006/main">
+<p:notes xmlns:a="http://schemas.openxmlformats.org/drawingml/2006/main" xmlns:r="http://schemas.openxmlformats.org/officeDocument/2006/relationships" xmlns:p="http://schemas.openxmlformats.org/presentationml/2006/main">
   <p:cSld>
     <p:spTree>
       <p:nvGrpSpPr>
@@ -365,27 +365,12 @@
           <a:chExt cx="0" cy="0"/>
         </a:xfrm>
       </p:grpSpPr>
-      <p:sp>
-        <p:nvSpPr>
-          <p:cNvPr id="2" name="Notes Placeholder 1"/>
-          <p:cNvSpPr/>
-          <p:nvPr/>
-        </p:nvSpPr>
-        <p:spPr>
-          <a:xfrm>
-            <a:off x="0" y="0"/>
-            <a:ext cx="6858000" cy="12192000"/>
-          </a:xfrm>
-        </p:spPr>
-        <p:txBody>
-          <a:bodyPr/>
-          <a:lstStyle/>
-          <a:p/>
-        </p:txBody>
-      </p:sp>
     </p:spTree>
   </p:cSld>
-</p:notesSlide>
+  <p:clrMapOvr>
+    <a:masterClrMapping/>
+  </p:clrMapOvr>
+</p:notes>
 </file>
 
 <file path=ppt/slideLayouts/slideLayout1.xml><?xml version="1.0" encoding="utf-8"?>
@@ -4402,159 +4387,1233 @@
 </p:sld>
 </file>
 
-<file path=ppt/slides/slide3.xml><?xml version="1.0" encoding="UTF-8" standalone="yes"?>
+<file path=ppt/slides/slide3.xml><?xml version="1.0" encoding="utf-8"?>
 <p:sld xmlns:a="http://schemas.openxmlformats.org/drawingml/2006/main" xmlns:r="http://schemas.openxmlformats.org/officeDocument/2006/relationships" xmlns:p="http://schemas.openxmlformats.org/presentationml/2006/main">
   <p:cSld name="Slide 3 - V2X">
-    <p:bg><p:bgPr><a:solidFill><a:srgbClr val="1D0638"/></a:solidFill><a:effectLst/></p:bgPr></p:bg>
+    <p:bg>
+      <p:bgPr>
+        <a:solidFill>
+          <a:srgbClr val="1D0638"/>
+        </a:solidFill>
+        <a:effectLst/>
+      </p:bgPr>
+    </p:bg>
     <p:spTree>
-      <p:nvGrpSpPr><p:cNvPr id="1" name=""/><p:cNvGrpSpPr/><p:nvPr/></p:nvGrpSpPr>
-      <p:grpSpPr><a:xfrm><a:off x="0" y="0"/><a:ext cx="0" cy="0"/><a:chOff x="0" y="0"/><a:chExt cx="0" cy="0"/></a:xfrm></p:grpSpPr>
-      <!-- Top line -->
-      <p:sp><p:nvSpPr><p:cNvPr id="2" name="TopLine"/><p:cNvSpPr/><p:nvPr/></p:nvSpPr>
-        <p:spPr><a:xfrm><a:off x="0" y="0"/><a:ext cx="12192000" cy="54864"/></a:xfrm><a:prstGeom prst="rect"><a:avLst/></a:prstGeom><a:solidFill><a:srgbClr val="442EE0"/></a:solidFill><a:ln/></p:spPr></p:sp>
-      <!-- Left bar -->
-      <p:sp><p:nvSpPr><p:cNvPr id="3" name="LeftBar"/><p:cNvSpPr/><p:nvPr/></p:nvSpPr>
-        <p:spPr><a:xfrm><a:off x="0" y="0"/><a:ext cx="73152" cy="6858000"/></a:xfrm><a:prstGeom prst="rect"><a:avLst/></a:prstGeom><a:solidFill><a:srgbClr val="442EE0"/></a:solidFill><a:ln/></p:spPr></p:sp>
-      <!-- Green dot -->
-      <p:sp><p:nvSpPr><p:cNvPr id="4" name="GreenDot"/><p:cNvSpPr/><p:nvPr/></p:nvSpPr>
-        <p:spPr><a:xfrm><a:off x="548640" y="411480"/><a:ext cx="228600" cy="228600"/></a:xfrm><a:prstGeom prst="ellipse"><a:avLst/></a:prstGeom><a:solidFill><a:srgbClr val="1EEF97"/></a:solidFill><a:ln/></p:spPr></p:sp>
-      <!-- CARIAD label -->
-      <p:sp><p:nvSpPr><p:cNvPr id="5" name="CARIAD"/><p:cNvSpPr/><p:nvPr/></p:nvSpPr>
-        <p:spPr><a:xfrm><a:off x="868680" y="384048"/><a:ext cx="2743200" cy="320040"/></a:xfrm><a:prstGeom prst="rect"><a:avLst/></a:prstGeom><a:noFill/><a:ln/></p:spPr>
-        <p:txBody><a:bodyPr wrap="square" rtlCol="0" anchor="t"/><a:lstStyle/>
-          <a:p><a:pPr marL="0" indent="0" algn="l"><a:buNone/></a:pPr><a:r><a:rPr lang="en-US" sz="1100" dirty="0"><a:solidFill><a:srgbClr val="CDCDD2"/></a:solidFill><a:latin typeface="Arial" pitchFamily="34" charset="0"/><a:ea typeface="Arial" pitchFamily="34" charset="-122"/></a:rPr><a:t>C A R I A D</a:t></a:r></a:p></p:txBody></p:sp>
-      <!-- Title -->
-      <p:sp><p:nvSpPr><p:cNvPr id="6" name="Title"/><p:cNvSpPr/><p:nvPr/></p:nvSpPr>
-        <p:spPr><a:xfrm><a:off x="526774" y="700000"/><a:ext cx="10972800" cy="640000"/></a:xfrm><a:prstGeom prst="rect"><a:avLst/></a:prstGeom><a:noFill/><a:ln/></p:spPr>
-        <p:txBody><a:bodyPr wrap="square" rtlCol="0" anchor="t"/><a:lstStyle/>
-          <a:p><a:pPr marL="0" indent="0" algn="l"><a:buNone/></a:pPr>
-            <a:r><a:rPr lang="en-US" sz="3200" b="1" dirty="0"><a:solidFill><a:srgbClr val="FFFFFF"/></a:solidFill><a:latin typeface="Arial" pitchFamily="34" charset="0"/><a:ea typeface="Arial" pitchFamily="34" charset="-122"/></a:rPr><a:t>V2X </a:t></a:r>
-            <a:r><a:rPr lang="en-US" sz="3200" b="1" dirty="0"><a:solidFill><a:srgbClr val="1EEF97"/></a:solidFill><a:latin typeface="Arial" pitchFamily="34" charset="0"/><a:ea typeface="Arial" pitchFamily="34" charset="-122"/></a:rPr><a:t>赋能</a:t></a:r>
-            <a:r><a:rPr lang="en-US" sz="3200" b="1" dirty="0"><a:solidFill><a:srgbClr val="FFFFFF"/></a:solidFill><a:latin typeface="Arial" pitchFamily="34" charset="0"/><a:ea typeface="Arial" pitchFamily="34" charset="-122"/></a:rPr><a:t> C-NCAP 2027 AEB 测试场景</a:t></a:r>
-          </a:p></p:txBody></p:sp>
-      <!-- Underline -->
-      <p:sp><p:nvSpPr><p:cNvPr id="7" name="Underline"/><p:cNvSpPr/><p:nvPr/></p:nvSpPr>
-        <p:spPr><a:xfrm><a:off x="526774" y="1340000"/><a:ext cx="2743200" cy="45720"/></a:xfrm><a:prstGeom prst="rect"><a:avLst/></a:prstGeom><a:solidFill><a:srgbClr val="1EEF97"/></a:solidFill><a:ln/></p:spPr></p:sp>
-      <!-- Subtitle -->
-      <p:sp><p:nvSpPr><p:cNvPr id="8" name="Subtitle"/><p:cNvSpPr/><p:nvPr/></p:nvSpPr>
-        <p:spPr><a:xfrm><a:off x="526774" y="1450000"/><a:ext cx="10972800" cy="274320"/></a:xfrm><a:prstGeom prst="rect"><a:avLst/></a:prstGeom><a:noFill/><a:ln/></p:spPr>
-        <p:txBody><a:bodyPr wrap="square" rtlCol="0" anchor="t"/><a:lstStyle/>
-          <a:p><a:pPr marL="0" indent="0" algn="l"><a:buNone/></a:pPr>
-            <a:r><a:rPr lang="zh-CN" sz="1400" dirty="0"><a:solidFill><a:srgbClr val="CDCDD2"/></a:solidFill><a:latin typeface="Arial" pitchFamily="34" charset="0"/><a:ea typeface="Microsoft YaHei" pitchFamily="34" charset="-122"/></a:rPr><a:t>V2V 车车直连 | V2P 车与弱势道路使用者 | V2I 车路协同 | 非视距穿透 · 恶劣天气抗扰 · 意图共享</a:t></a:r>
-          </a:p></p:txBody></p:sp>
-      <!-- Vertical divider -->
-      <p:sp><p:nvSpPr><p:cNvPr id="9" name="VLine"/><p:cNvSpPr/><p:nvPr/></p:nvSpPr>
-        <p:spPr><a:xfrm><a:off x="6131451" y="1850000"/><a:ext cx="45719" cy="4200000"/></a:xfrm><a:prstGeom prst="rect"><a:avLst/></a:prstGeom><a:solidFill><a:srgbClr val="442EE0"/></a:solidFill><a:ln/></p:spPr></p:sp>
-      <!-- Left header -->
-      <p:sp><p:nvSpPr><p:cNvPr id="10" name="LeftHeader"/><p:cNvSpPr/><p:nvPr/></p:nvSpPr>
-        <p:spPr><a:xfrm><a:off x="526774" y="1820000"/><a:ext cx="5100000" cy="320040"/></a:xfrm><a:prstGeom prst="rect"><a:avLst/></a:prstGeom><a:noFill/><a:ln/></p:spPr>
-        <p:txBody><a:bodyPr wrap="square" rtlCol="0" anchor="t"/><a:lstStyle/>
-          <a:p><a:pPr marL="0" indent="0" algn="l"><a:buNone/></a:pPr>
-            <a:r><a:rPr lang="en-US" sz="1100" b="1" dirty="0"><a:solidFill><a:srgbClr val="1EEF97"/></a:solidFill><a:latin typeface="Arial" pitchFamily="34" charset="0"/><a:ea typeface="Arial" pitchFamily="34" charset="-122"/></a:rPr><a:t>附录P — VRU场景 | V2P / 车与弱势道路使用者</a:t></a:r>
-          </a:p></p:txBody></p:sp>
-      <!-- Left list -->
-      <p:sp><p:nvSpPr><p:cNvPr id="11" name="LeftList"/><p:cNvSpPr/><p:nvPr/></p:nvSpPr>
-        <p:spPr><a:xfrm><a:off x="526774" y="2160000"/><a:ext cx="5100000" cy="4000000"/></a:xfrm><a:prstGeom prst="rect"><a:avLst/></a:prstGeom><a:noFill/><a:ln/></p:spPr>
-        <p:txBody><a:bodyPr wrap="square" rtlCol="0" anchor="t"/><a:lstStyle/><a:p><a:pPr marL="0" indent="0" algn="l"><a:buNone/></a:pPr>
-          <a:r><a:rPr lang="zh-CN" sz="900" b="1" dirty="0"><a:solidFill><a:srgbClr val="1EEF97"/></a:solidFill><a:latin typeface="Arial" pitchFamily="34" charset="0"/><a:ea typeface="Microsoft YaHei" pitchFamily="34" charset="-122"/></a:rPr><a:t>V2P 穿透遮挡 — 行人/二轮车感知</a:t></a:r></a:p><a:p><a:pPr marL="171450" indent="0" algn="l"><a:buNone/></a:pPr>
-          <a:r><a:rPr lang="zh-CN" sz="700" dirty="0"><a:solidFill><a:srgbClr val="CDCDD2"/></a:solidFill><a:latin typeface="Arial" pitchFamily="34" charset="0"/><a:ea typeface="Microsoft YaHei" pitchFamily="34" charset="-122"/></a:rPr><a:t>CPFC-MO 动态遮挡儿童 — 被挡儿童可被V2P提前感知</a:t></a:r></a:p><a:p><a:pPr marL="171450" indent="0" algn="l"><a:buNone/></a:pPr>
-          <a:r><a:rPr lang="zh-CN" sz="700" dirty="0"><a:solidFill><a:srgbClr val="CDCDD2"/></a:solidFill><a:latin typeface="Arial" pitchFamily="34" charset="0"/><a:ea typeface="Microsoft YaHei" pitchFamily="34" charset="-122"/></a:rPr><a:t>CPNC-AI / CPFC-BI 干扰横穿 — 被遮挡弱势道路使用者</a:t></a:r></a:p><a:p><a:pPr marL="171450" indent="0" algn="l"><a:buNone/></a:pPr>
-          <a:r><a:rPr lang="zh-CN" sz="700" dirty="0"><a:solidFill><a:srgbClr val="CDCDD2"/></a:solidFill><a:latin typeface="Arial" pitchFamily="34" charset="0"/><a:ea typeface="Microsoft YaHei" pitchFamily="34" charset="-122"/></a:rPr><a:t>CBOFA / CBFA-MO 遮挡斜穿 — 穿透车辆障碍</a:t></a:r></a:p><a:p><a:pPr marL="171450" indent="0" algn="l"><a:buNone/></a:pPr>
-          <a:r><a:rPr lang="zh-CN" sz="700" dirty="0"><a:solidFill><a:srgbClr val="CDCDD2"/></a:solidFill><a:latin typeface="Arial" pitchFamily="34" charset="0"/><a:ea typeface="Microsoft YaHei" pitchFamily="34" charset="-122"/></a:rPr><a:t>CBNA-AI / CSFA-BI 干扰近端 — V2P弥补盲区</a:t></a:r></a:p><a:p><a:pPr marL="171450" indent="0" algn="l"><a:buNone/></a:pPr>
-          <a:r><a:rPr lang="zh-CN" sz="700" dirty="0"><a:solidFill><a:srgbClr val="CDCDD2"/></a:solidFill><a:latin typeface="Arial" pitchFamily="34" charset="0"/><a:ea typeface="Microsoft YaHei" pitchFamily="34" charset="-122"/></a:rPr><a:t>CSTAO-RN 右转遮挡 — 路侧V2I+车端V2P协同</a:t></a:r></a:p><a:p><a:pPr marL="0" indent="0" algn="l"><a:buNone/></a:pPr><a:endParaRPr lang="zh-CN" sz="300" dirty="0"/></a:p><a:p><a:pPr marL="0" indent="0" algn="l"><a:buNone/></a:pPr>
-          <a:r><a:rPr lang="zh-CN" sz="900" b="1" dirty="0"><a:solidFill><a:srgbClr val="1EEF97"/></a:solidFill><a:latin typeface="Arial" pitchFamily="34" charset="0"/><a:ea typeface="Microsoft YaHei" pitchFamily="34" charset="-122"/></a:rPr><a:t>V2P 转弯/横穿预警</a:t></a:r></a:p><a:p><a:pPr marL="171450" indent="0" algn="l"><a:buNone/></a:pPr>
-          <a:r><a:rPr lang="zh-CN" sz="700" dirty="0"><a:solidFill><a:srgbClr val="CDCDD2"/></a:solidFill><a:latin typeface="Arial" pitchFamily="34" charset="0"/><a:ea typeface="Microsoft YaHei" pitchFamily="34" charset="-122"/></a:rPr><a:t>CPTA-LF / CPTA-RF 转弯横穿行人 — 提前感知意图</a:t></a:r></a:p><a:p><a:pPr marL="171450" indent="0" algn="l"><a:buNone/></a:pPr>
-          <a:r><a:rPr lang="zh-CN" sz="700" dirty="0"><a:solidFill><a:srgbClr val="CDCDD2"/></a:solidFill><a:latin typeface="Arial" pitchFamily="34" charset="0"/><a:ea typeface="Microsoft YaHei" pitchFamily="34" charset="-122"/></a:rPr><a:t>C2S RCPf / C2B RCPn 转弯横穿二轮 — 路口盲区</a:t></a:r></a:p><a:p><a:pPr marL="171450" indent="0" algn="l"><a:buNone/></a:pPr>
-          <a:r><a:rPr lang="zh-CN" sz="700" dirty="0"><a:solidFill><a:srgbClr val="CDCDD2"/></a:solidFill><a:latin typeface="Arial" pitchFamily="34" charset="0"/><a:ea typeface="Microsoft YaHei" pitchFamily="34" charset="-122"/></a:rPr><a:t>CBLAt 转弯切入 / CBLAc 变道切入 — V2P/V2V共享意图</a:t></a:r></a:p><a:p><a:pPr marL="171450" indent="0" algn="l"><a:buNone/></a:pPr>
-          <a:r><a:rPr lang="zh-CN" sz="700" dirty="0"><a:solidFill><a:srgbClr val="CDCDD2"/></a:solidFill><a:latin typeface="Arial" pitchFamily="34" charset="0"/><a:ea typeface="Microsoft YaHei" pitchFamily="34" charset="-122"/></a:rPr><a:t>CSFhol 直行对向二轮 — 远距离V2P预警</a:t></a:r></a:p><a:p><a:pPr marL="0" indent="0" algn="l"><a:buNone/></a:pPr><a:endParaRPr lang="zh-CN" sz="300" dirty="0"/></a:p><a:p><a:pPr marL="0" indent="0" algn="l"><a:buNone/></a:pPr>
-          <a:r><a:rPr lang="zh-CN" sz="900" b="1" dirty="0"><a:solidFill><a:srgbClr val="442EE0"/></a:solidFill><a:latin typeface="Arial" pitchFamily="34" charset="0"/><a:ea typeface="Microsoft YaHei" pitchFamily="34" charset="-122"/></a:rPr><a:t>恶劣环境优势 — 天气/光照</a:t></a:r></a:p><a:p><a:pPr marL="171450" indent="0" algn="l"><a:buNone/></a:pPr>
-          <a:r><a:rPr lang="zh-CN" sz="700" dirty="0"><a:solidFill><a:srgbClr val="CDCDD2"/></a:solidFill><a:latin typeface="Arial" pitchFamily="34" charset="0"/><a:ea typeface="Microsoft YaHei" pitchFamily="34" charset="-122"/></a:rPr><a:t>CPFAr 雨天远端横穿 — 摄像头受限，V2X不受影响</a:t></a:r></a:p><a:p><a:pPr marL="171450" indent="0" algn="l"><a:buNone/></a:pPr>
-          <a:r><a:rPr lang="zh-CN" sz="700" dirty="0"><a:solidFill><a:srgbClr val="CDCDD2"/></a:solidFill><a:latin typeface="Arial" pitchFamily="34" charset="0"/><a:ea typeface="Microsoft YaHei" pitchFamily="34" charset="-122"/></a:rPr><a:t>CBLAb 电动自行车夜间 — 弱光下V2P优于视觉</a:t></a:r></a:p><a:p><a:pPr marL="171450" indent="0" algn="l"><a:buNone/></a:pPr>
-          <a:r><a:rPr lang="zh-CN" sz="700" dirty="0"><a:solidFill><a:srgbClr val="CDCDD2"/></a:solidFill><a:latin typeface="Arial" pitchFamily="34" charset="0"/><a:ea typeface="Microsoft YaHei" pitchFamily="34" charset="-122"/></a:rPr><a:t>CPFAh / CPLAh 高速场景 — 远距离V2P提前预警</a:t></a:r></a:p><a:p><a:pPr marL="0" indent="0" algn="l"><a:buNone/></a:pPr><a:endParaRPr lang="zh-CN" sz="300" dirty="0"/></a:p></p:txBody></p:sp>
-      <!-- Right header -->
-      <p:sp><p:nvSpPr><p:cNvPr id="20" name="RightHeader"/><p:cNvSpPr/><p:nvPr/></p:nvSpPr>
-        <p:spPr><a:xfrm><a:off x="6636028" y="1820000"/><a:ext cx="5100000" cy="320040"/></a:xfrm><a:prstGeom prst="rect"><a:avLst/></a:prstGeom><a:noFill/><a:ln/></p:spPr>
-        <p:txBody><a:bodyPr wrap="square" rtlCol="0" anchor="t"/><a:lstStyle/>
-          <a:p><a:pPr marL="0" indent="0" algn="l"><a:buNone/></a:pPr>
-            <a:r><a:rPr lang="en-US" sz="1100" b="1" dirty="0"><a:solidFill><a:srgbClr val="1EEF97"/></a:solidFill><a:latin typeface="Arial" pitchFamily="34" charset="0"/><a:ea typeface="Arial" pitchFamily="34" charset="-122"/></a:rPr><a:t>附录Q — C2C场景 | V2V / V2I 车车与车路协同</a:t></a:r>
-          </a:p></p:txBody></p:sp>
-      <!-- Right list -->
-      <p:sp><p:nvSpPr><p:cNvPr id="21" name="RightList"/><p:cNvSpPr/><p:nvPr/></p:nvSpPr>
-        <p:spPr><a:xfrm><a:off x="6636028" y="2160000"/><a:ext cx="5100000" cy="4000000"/></a:xfrm><a:prstGeom prst="rect"><a:avLst/></a:prstGeom><a:noFill/><a:ln/></p:spPr>
-        <p:txBody><a:bodyPr wrap="square" rtlCol="0" anchor="t"/><a:lstStyle/><a:p><a:pPr marL="0" indent="0" algn="l"><a:buNone/></a:pPr>
-          <a:r><a:rPr lang="zh-CN" sz="900" b="1" dirty="0"><a:solidFill><a:srgbClr val="1EEF97"/></a:solidFill><a:latin typeface="Arial" pitchFamily="34" charset="0"/><a:ea typeface="Microsoft YaHei" pitchFamily="34" charset="-122"/></a:rPr><a:t>V2V 遮挡/非视距 — 穿透障碍</a:t></a:r></a:p><a:p><a:pPr marL="171450" indent="0" algn="l"><a:buNone/></a:pPr>
-          <a:r><a:rPr lang="zh-CN" sz="700" dirty="0"><a:solidFill><a:srgbClr val="CDCDD2"/></a:solidFill><a:latin typeface="Arial" pitchFamily="34" charset="0"/><a:ea typeface="Microsoft YaHei" pitchFamily="34" charset="-122"/></a:rPr><a:t>C2C SCPmo 动态遮挡横穿 — 被挡车辆V2V预警</a:t></a:r></a:p><a:p><a:pPr marL="171450" indent="0" algn="l"><a:buNone/></a:pPr>
-          <a:r><a:rPr lang="zh-CN" sz="700" dirty="0"><a:solidFill><a:srgbClr val="CDCDD2"/></a:solidFill><a:latin typeface="Arial" pitchFamily="34" charset="0"/><a:ea typeface="Microsoft YaHei" pitchFamily="34" charset="-122"/></a:rPr><a:t>C2C SCPso 静态遮挡横穿 — 越过建筑物/车辆感知</a:t></a:r></a:p><a:p><a:pPr marL="171450" indent="0" algn="l"><a:buNone/></a:pPr>
-          <a:r><a:rPr lang="zh-CN" sz="700" dirty="0"><a:solidFill><a:srgbClr val="CDCDD2"/></a:solidFill><a:latin typeface="Arial" pitchFamily="34" charset="0"/><a:ea typeface="Microsoft YaHei" pitchFamily="34" charset="-122"/></a:rPr><a:t>CCFT / CCFTf 转弯对撞 — 路口建筑遮挡，V2V直连</a:t></a:r></a:p><a:p><a:pPr marL="171450" indent="0" algn="l"><a:buNone/></a:pPr>
-          <a:r><a:rPr lang="zh-CN" sz="700" dirty="0"><a:solidFill><a:srgbClr val="CDCDD2"/></a:solidFill><a:latin typeface="Arial" pitchFamily="34" charset="0"/><a:ea typeface="Microsoft YaHei" pitchFamily="34" charset="-122"/></a:rPr><a:t>LCPf / LCPn 左转横穿 — 对向遮挡车辆提前通信</a:t></a:r></a:p><a:p><a:pPr marL="0" indent="0" algn="l"><a:buNone/></a:pPr><a:endParaRPr lang="zh-CN" sz="300" dirty="0"/></a:p><a:p><a:pPr marL="0" indent="0" algn="l"><a:buNone/></a:pPr>
-          <a:r><a:rPr lang="zh-CN" sz="900" b="1" dirty="0"><a:solidFill><a:srgbClr val="1EEF97"/></a:solidFill><a:latin typeface="Arial" pitchFamily="34" charset="0"/><a:ea typeface="Microsoft YaHei" pitchFamily="34" charset="-122"/></a:rPr><a:t>V2V 恶劣天气 — 传感器降级</a:t></a:r></a:p><a:p><a:pPr marL="171450" indent="0" algn="l"><a:buNone/></a:pPr>
-          <a:r><a:rPr lang="zh-CN" sz="700" dirty="0"><a:solidFill><a:srgbClr val="CDCDD2"/></a:solidFill><a:latin typeface="Arial" pitchFamily="34" charset="0"/><a:ea typeface="Microsoft YaHei" pitchFamily="34" charset="-122"/></a:rPr><a:t>CCRsr 雨天追尾 — 雷达/摄像头衰减，V2V不受影响</a:t></a:r></a:p><a:p><a:pPr marL="171450" indent="0" algn="l"><a:buNone/></a:pPr>
-          <a:r><a:rPr lang="zh-CN" sz="700" dirty="0"><a:solidFill><a:srgbClr val="CDCDD2"/></a:solidFill><a:latin typeface="Arial" pitchFamily="34" charset="0"/><a:ea typeface="Microsoft YaHei" pitchFamily="34" charset="-122"/></a:rPr><a:t>CCRsf 雾天追尾 — 能见度极低，V2V稳定通信</a:t></a:r></a:p><a:p><a:pPr marL="171450" indent="0" algn="l"><a:buNone/></a:pPr>
-          <a:r><a:rPr lang="zh-CN" sz="700" dirty="0"><a:solidFill><a:srgbClr val="CDCDD2"/></a:solidFill><a:latin typeface="Arial" pitchFamily="34" charset="0"/><a:ea typeface="Microsoft YaHei" pitchFamily="34" charset="-122"/></a:rPr><a:t>CCFhos 直行对撞 — 雨雾天远距离V2V预警</a:t></a:r></a:p><a:p><a:pPr marL="0" indent="0" algn="l"><a:buNone/></a:pPr><a:endParaRPr lang="zh-CN" sz="300" dirty="0"/></a:p><a:p><a:pPr marL="0" indent="0" algn="l"><a:buNone/></a:pPr>
-          <a:r><a:rPr lang="zh-CN" sz="900" b="1" dirty="0"><a:solidFill><a:srgbClr val="442EE0"/></a:solidFill><a:latin typeface="Arial" pitchFamily="34" charset="0"/><a:ea typeface="Microsoft YaHei" pitchFamily="34" charset="-122"/></a:rPr><a:t>V2V 意图共享 — 切入/制动</a:t></a:r></a:p><a:p><a:pPr marL="171450" indent="0" algn="l"><a:buNone/></a:pPr>
-          <a:r><a:rPr lang="zh-CN" sz="700" dirty="0"><a:solidFill><a:srgbClr val="CDCDD2"/></a:solidFill><a:latin typeface="Arial" pitchFamily="34" charset="0"/><a:ea typeface="Microsoft YaHei" pitchFamily="34" charset="-122"/></a:rPr><a:t>CCRc 切入追尾 — 邻车变道意图实时共享</a:t></a:r></a:p><a:p><a:pPr marL="171450" indent="0" algn="l"><a:buNone/></a:pPr>
-          <a:r><a:rPr lang="zh-CN" sz="700" dirty="0"><a:solidFill><a:srgbClr val="CDCDD2"/></a:solidFill><a:latin typeface="Arial" pitchFamily="34" charset="0"/><a:ea typeface="Microsoft YaHei" pitchFamily="34" charset="-122"/></a:rPr><a:t>CCRb 制动追尾 — 前车制动信号低延迟广播</a:t></a:r></a:p><a:p><a:pPr marL="171450" indent="0" algn="l"><a:buNone/></a:pPr>
-          <a:r><a:rPr lang="zh-CN" sz="700" dirty="0"><a:solidFill><a:srgbClr val="CDCDD2"/></a:solidFill><a:latin typeface="Arial" pitchFamily="34" charset="0"/><a:ea typeface="Microsoft YaHei" pitchFamily="34" charset="-122"/></a:rPr><a:t>CCRh 高速追尾 — 超视距提前获知前车减速</a:t></a:r></a:p><a:p><a:pPr marL="171450" indent="0" algn="l"><a:buNone/></a:pPr>
-          <a:r><a:rPr lang="zh-CN" sz="700" dirty="0"><a:solidFill><a:srgbClr val="CDCDD2"/></a:solidFill><a:latin typeface="Arial" pitchFamily="34" charset="0"/><a:ea typeface="Microsoft YaHei" pitchFamily="34" charset="-122"/></a:rPr><a:t>CCRbc 弯道制动 — 弯道遮挡场景V2V补盲</a:t></a:r></a:p><a:p><a:pPr marL="171450" indent="0" algn="l"><a:buNone/></a:pPr>
-          <a:r><a:rPr lang="zh-CN" sz="700" dirty="0"><a:solidFill><a:srgbClr val="CDCDD2"/></a:solidFill><a:latin typeface="Arial" pitchFamily="34" charset="0"/><a:ea typeface="Microsoft YaHei" pitchFamily="34" charset="-122"/></a:rPr><a:t>RCPf 右转横穿 — 转向意图+位置共享</a:t></a:r></a:p><a:p><a:pPr marL="0" indent="0" algn="l"><a:buNone/></a:pPr><a:endParaRPr lang="zh-CN" sz="300" dirty="0"/></a:p><a:p><a:pPr marL="0" indent="0" algn="l"><a:buNone/></a:pPr>
-          <a:r><a:rPr lang="zh-CN" sz="900" b="1" dirty="0"><a:solidFill><a:srgbClr val="442EE0"/></a:solidFill><a:latin typeface="Arial" pitchFamily="34" charset="0"/><a:ea typeface="Microsoft YaHei" pitchFamily="34" charset="-122"/></a:rPr><a:t>V2I 路侧协同</a:t></a:r></a:p><a:p><a:pPr marL="171450" indent="0" algn="l"><a:buNone/></a:pPr>
-          <a:r><a:rPr lang="zh-CN" sz="700" dirty="0"><a:solidFill><a:srgbClr val="CDCDD2"/></a:solidFill><a:latin typeface="Arial" pitchFamily="34" charset="0"/><a:ea typeface="Microsoft YaHei" pitchFamily="34" charset="-122"/></a:rPr><a:t>所有十字路口转弯/横穿场景均可通过V2I路侧单元(RSU)</a:t></a:r></a:p><a:p><a:pPr marL="171450" indent="0" algn="l"><a:buNone/></a:pPr>
-          <a:r><a:rPr lang="zh-CN" sz="700" dirty="0"><a:solidFill><a:srgbClr val="CDCDD2"/></a:solidFill><a:latin typeface="Arial" pitchFamily="34" charset="0"/><a:ea typeface="Microsoft YaHei" pitchFamily="34" charset="-122"/></a:rPr><a:t>获取路口全局目标列表，弥补单车感知盲区</a:t></a:r></a:p><a:p><a:pPr marL="171450" indent="0" algn="l"><a:buNone/></a:pPr>
-          <a:r><a:rPr lang="zh-CN" sz="700" dirty="0"><a:solidFill><a:srgbClr val="CDCDD2"/></a:solidFill><a:latin typeface="Arial" pitchFamily="34" charset="0"/><a:ea typeface="Microsoft YaHei" pitchFamily="34" charset="-122"/></a:rPr><a:t>典型: CPTA系列 / CCFT系列 / C2C LCP&SCP系列</a:t></a:r></a:p><a:p><a:pPr marL="0" indent="0" algn="l"><a:buNone/></a:pPr><a:endParaRPr lang="zh-CN" sz="300" dirty="0"/></a:p></p:txBody></p:sp>
-      <!-- Bottom separator -->
-      <p:sp><p:nvSpPr><p:cNvPr id="90" name="BtmLine"/><p:cNvSpPr/><p:nvPr/></p:nvSpPr>
-        <p:spPr><a:xfrm><a:off x="526774" y="5900000"/><a:ext cx="11064240" cy="10973"/></a:xfrm><a:prstGeom prst="rect"><a:avLst/></a:prstGeom><a:solidFill><a:srgbClr val="373741"/></a:solidFill><a:ln/></p:spPr></p:sp>
-      <!-- Stats row -->
-      <p:sp><p:nvSpPr><p:cNvPr id="91" name="Stat1"/><p:cNvSpPr/><p:nvPr/></p:nvSpPr>
-        <p:spPr><a:xfrm><a:off x="526774" y="5970000"/><a:ext cx="2743200" cy="292608"/></a:xfrm><a:prstGeom prst="rect"><a:avLst/></a:prstGeom><a:noFill/><a:ln/></p:spPr>
-        <p:txBody><a:bodyPr wrap="square" rtlCol="0" anchor="t"/><a:lstStyle/>
-          <a:p><a:pPr marL="0" indent="0" algn="l"><a:buNone/></a:pPr>
-            <a:r><a:rPr lang="en-US" sz="1600" b="1" dirty="0"><a:solidFill><a:srgbClr val="1EEF97"/></a:solidFill><a:latin typeface="Arial" pitchFamily="34" charset="0"/><a:ea typeface="Arial" pitchFamily="34" charset="-122"/></a:rPr><a:t>~70%</a:t></a:r></a:p></p:txBody></p:sp>
-      <p:sp><p:nvSpPr><p:cNvPr id="92" name="Stat1Label"/><p:cNvSpPr/><p:nvPr/></p:nvSpPr>
-        <p:spPr><a:xfrm><a:off x="526774" y="6215000"/><a:ext cx="2743200" cy="182880"/></a:xfrm><a:prstGeom prst="rect"><a:avLst/></a:prstGeom><a:noFill/><a:ln/></p:spPr>
-        <p:txBody><a:bodyPr wrap="square" rtlCol="0" anchor="t"/><a:lstStyle/>
-          <a:p><a:pPr marL="0" indent="0" algn="l"><a:buNone/></a:pPr>
-            <a:r><a:rPr lang="zh-CN" sz="800" dirty="0"><a:solidFill><a:srgbClr val="CDCDD2"/></a:solidFill><a:latin typeface="Arial" pitchFamily="34" charset="0"/><a:ea typeface="Microsoft YaHei" pitchFamily="34" charset="-122"/></a:rPr><a:t>场景可由V2X增强</a:t></a:r></a:p></p:txBody></p:sp>
-      <p:sp><p:nvSpPr><p:cNvPr id="93" name="Stat2"/><p:cNvSpPr/><p:nvPr/></p:nvSpPr>
-        <p:spPr><a:xfrm><a:off x="3292834" y="5970000"/><a:ext cx="2743200" cy="292608"/></a:xfrm><a:prstGeom prst="rect"><a:avLst/></a:prstGeom><a:noFill/><a:ln/></p:spPr>
-        <p:txBody><a:bodyPr wrap="square" rtlCol="0" anchor="t"/><a:lstStyle/>
-          <a:p><a:pPr marL="0" indent="0" algn="l"><a:buNone/></a:pPr>
-            <a:r><a:rPr lang="en-US" sz="1600" b="1" dirty="0"><a:solidFill><a:srgbClr val="1EEF97"/></a:solidFill><a:latin typeface="Arial" pitchFamily="34" charset="0"/><a:ea typeface="Arial" pitchFamily="34" charset="-122"/></a:rPr><a:t>V2V+P+I</a:t></a:r></a:p></p:txBody></p:sp>
-      <p:sp><p:nvSpPr><p:cNvPr id="94" name="Stat2Label"/><p:cNvSpPr/><p:nvPr/></p:nvSpPr>
-        <p:spPr><a:xfrm><a:off x="3292834" y="6215000"/><a:ext cx="2743200" cy="182880"/></a:xfrm><a:prstGeom prst="rect"><a:avLst/></a:prstGeom><a:noFill/><a:ln/></p:spPr>
-        <p:txBody><a:bodyPr wrap="square" rtlCol="0" anchor="t"/><a:lstStyle/>
-          <a:p><a:pPr marL="0" indent="0" algn="l"><a:buNone/></a:pPr>
-            <a:r><a:rPr lang="zh-CN" sz="800" dirty="0"><a:solidFill><a:srgbClr val="CDCDD2"/></a:solidFill><a:latin typeface="Arial" pitchFamily="34" charset="0"/><a:ea typeface="Microsoft YaHei" pitchFamily="34" charset="-122"/></a:rPr><a:t>V2X通信模式协同</a:t></a:r></a:p></p:txBody></p:sp>
-      <p:sp><p:nvSpPr><p:cNvPr id="95" name="Stat3"/><p:cNvSpPr/><p:nvPr/></p:nvSpPr>
-        <p:spPr><a:xfrm><a:off x="6357863" y="5970000"/><a:ext cx="2743200" cy="292608"/></a:xfrm><a:prstGeom prst="rect"><a:avLst/></a:prstGeom><a:noFill/><a:ln/></p:spPr>
-        <p:txBody><a:bodyPr wrap="square" rtlCol="0" anchor="t"/><a:lstStyle/>
-          <a:p><a:pPr marL="0" indent="0" algn="l"><a:buNone/></a:pPr>
-            <a:r><a:rPr lang="en-US" sz="1600" b="1" dirty="0"><a:solidFill><a:srgbClr val="1EEF97"/></a:solidFill><a:latin typeface="Arial" pitchFamily="34" charset="0"/><a:ea typeface="Arial" pitchFamily="34" charset="-122"/></a:rPr><a:t>NLOS</a:t></a:r></a:p></p:txBody></p:sp>
-      <p:sp><p:nvSpPr><p:cNvPr id="96" name="Stat3Label"/><p:cNvSpPr/><p:nvPr/></p:nvSpPr>
-        <p:spPr><a:xfrm><a:off x="6357863" y="6195000"/><a:ext cx="2743200" cy="182880"/></a:xfrm><a:prstGeom prst="rect"><a:avLst/></a:prstGeom><a:noFill/><a:ln/></p:spPr>
-        <p:txBody><a:bodyPr wrap="square" rtlCol="0" anchor="t"/><a:lstStyle/>
-          <a:p><a:pPr marL="0" indent="0" algn="l"><a:buNone/></a:pPr>
-            <a:r><a:rPr lang="zh-CN" sz="800" dirty="0"><a:solidFill><a:srgbClr val="CDCDD2"/></a:solidFill><a:latin typeface="Arial" pitchFamily="34" charset="0"/><a:ea typeface="Microsoft YaHei" pitchFamily="34" charset="-122"/></a:rPr><a:t>非视距穿透是核心优势</a:t></a:r></a:p></p:txBody></p:sp>
-      <p:sp><p:nvSpPr><p:cNvPr id="97" name="Stat4"/><p:cNvSpPr/><p:nvPr/></p:nvSpPr>
-        <p:spPr><a:xfrm><a:off x="9123923" y="5970000"/><a:ext cx="2743200" cy="292608"/></a:xfrm><a:prstGeom prst="rect"><a:avLst/></a:prstGeom><a:noFill/><a:ln/></p:spPr>
-        <p:txBody><a:bodyPr wrap="square" rtlCol="0" anchor="t"/><a:lstStyle/>
-          <a:p><a:pPr marL="0" indent="0" algn="l"><a:buNone/></a:pPr>
-            <a:r><a:rPr lang="en-US" sz="1600" b="1" dirty="0"><a:solidFill><a:srgbClr val="1EEF97"/></a:solidFill><a:latin typeface="Arial" pitchFamily="34" charset="0"/><a:ea typeface="Arial" pitchFamily="34" charset="-122"/></a:rPr><a:t>全天候</a:t></a:r></a:p></p:txBody></p:sp>
-      <p:sp><p:nvSpPr><p:cNvPr id="98" name="Stat4Label"/><p:cNvSpPr/><p:nvPr/></p:nvSpPr>
-        <p:spPr><a:xfrm><a:off x="9123923" y="6195000"/><a:ext cx="2743200" cy="182880"/></a:xfrm><a:prstGeom prst="rect"><a:avLst/></a:prstGeom><a:noFill/><a:ln/></p:spPr>
-        <p:txBody><a:bodyPr wrap="square" rtlCol="0" anchor="t"/><a:lstStyle/>
-          <a:p><a:pPr marL="0" indent="0" algn="l"><a:buNone/></a:pPr>
-            <a:r><a:rPr lang="zh-CN" sz="800" dirty="0"><a:solidFill><a:srgbClr val="CDCDD2"/></a:solidFill><a:latin typeface="Arial" pitchFamily="34" charset="0"/><a:ea typeface="Microsoft YaHei" pitchFamily="34" charset="-122"/></a:rPr><a:t>雨雾夜不受影响</a:t></a:r></a:p></p:txBody></p:sp>
-      <!-- Footer -->
-      <p:sp><p:nvSpPr><p:cNvPr id="99" name="Footer"/><p:cNvSpPr/><p:nvPr/></p:nvSpPr>
-        <p:spPr><a:xfrm><a:off x="526774" y="6500000"/><a:ext cx="4572000" cy="137160"/></a:xfrm><a:prstGeom prst="rect"><a:avLst/></a:prstGeom><a:noFill/><a:ln/></p:spPr>
-        <p:txBody><a:bodyPr wrap="square" rtlCol="0" anchor="t"/><a:lstStyle/>
-          <a:p><a:pPr marL="0" indent="0" algn="l"><a:buNone/></a:pPr>
-            <a:r><a:rPr lang="zh-CN" sz="700" dirty="0"><a:solidFill><a:srgbClr val="888888"/></a:solidFill><a:latin typeface="Arial" pitchFamily="34" charset="0"/><a:ea typeface="Microsoft YaHei" pitchFamily="34" charset="-122"/></a:rPr><a:t>INTERNAL / CONFIDENTIAL  |  CSD class: 2.5  |  基于 C-NCAP 2027 场景的 V2X 赋能分析</a:t></a:r>
-          </a:p></p:txBody></p:sp>
+      <p:nvGrpSpPr>
+        <p:cNvPr id="1" name=""/>
+        <p:cNvGrpSpPr/>
+        <p:nvPr/>
+      </p:nvGrpSpPr>
+      <p:grpSpPr>
+        <a:xfrm>
+          <a:off x="0" y="0"/>
+          <a:ext cx="0" cy="0"/>
+          <a:chOff x="0" y="0"/>
+          <a:chExt cx="0" cy="0"/>
+        </a:xfrm>
+      </p:grpSpPr>
+      <p:sp>
+        <p:nvSpPr>
+          <p:cNvPr id="2" name="TopLine"/>
+          <p:cNvSpPr/>
+          <p:nvPr/>
+        </p:nvSpPr>
+        <p:spPr>
+          <a:xfrm>
+            <a:off x="0" y="0"/>
+            <a:ext cx="12192000" cy="54864"/>
+          </a:xfrm>
+          <a:prstGeom prst="rect">
+            <a:avLst/>
+          </a:prstGeom>
+          <a:solidFill>
+            <a:srgbClr val="442EE0"/>
+          </a:solidFill>
+          <a:ln/>
+        </p:spPr>
+      </p:sp>
+      <p:sp>
+        <p:nvSpPr>
+          <p:cNvPr id="3" name="LeftBar"/>
+          <p:cNvSpPr/>
+          <p:nvPr/>
+        </p:nvSpPr>
+        <p:spPr>
+          <a:xfrm>
+            <a:off x="0" y="0"/>
+            <a:ext cx="73152" cy="6858000"/>
+          </a:xfrm>
+          <a:prstGeom prst="rect">
+            <a:avLst/>
+          </a:prstGeom>
+          <a:solidFill>
+            <a:srgbClr val="442EE0"/>
+          </a:solidFill>
+          <a:ln/>
+        </p:spPr>
+      </p:sp>
+      <p:sp>
+        <p:nvSpPr>
+          <p:cNvPr id="4" name="GreenDot"/>
+          <p:cNvSpPr/>
+          <p:nvPr/>
+        </p:nvSpPr>
+        <p:spPr>
+          <a:xfrm>
+            <a:off x="548640" y="411480"/>
+            <a:ext cx="228600" cy="228600"/>
+          </a:xfrm>
+          <a:prstGeom prst="ellipse">
+            <a:avLst/>
+          </a:prstGeom>
+          <a:solidFill>
+            <a:srgbClr val="1EEF97"/>
+          </a:solidFill>
+          <a:ln/>
+        </p:spPr>
+      </p:sp>
+      <p:sp>
+        <p:nvSpPr>
+          <p:cNvPr id="5" name="CARIAD"/>
+          <p:cNvSpPr/>
+          <p:nvPr/>
+        </p:nvSpPr>
+        <p:spPr>
+          <a:xfrm>
+            <a:off x="868680" y="384048"/>
+            <a:ext cx="2743200" cy="320040"/>
+          </a:xfrm>
+          <a:prstGeom prst="rect">
+            <a:avLst/>
+          </a:prstGeom>
+          <a:noFill/>
+          <a:ln/>
+        </p:spPr>
+        <p:txBody>
+          <a:bodyPr wrap="square" rtlCol="0" anchor="t"/>
+          <a:lstStyle/>
+          <a:p>
+            <a:pPr marL="0" indent="0" algn="l">
+              <a:buNone/>
+            </a:pPr>
+            <a:r>
+              <a:rPr lang="en-US" sz="1100" dirty="0">
+                <a:solidFill>
+                  <a:srgbClr val="CDCDD2"/>
+                </a:solidFill>
+                <a:latin typeface="Arial" pitchFamily="34" charset="0"/>
+                <a:ea typeface="Arial" pitchFamily="34" charset="-122"/>
+              </a:rPr>
+              <a:t>C A R I A D</a:t>
+            </a:r>
+          </a:p>
+        </p:txBody>
+      </p:sp>
+      <p:sp>
+        <p:nvSpPr>
+          <p:cNvPr id="6" name="MainTitle"/>
+          <p:cNvSpPr/>
+          <p:nvPr/>
+        </p:nvSpPr>
+        <p:spPr>
+          <a:xfrm>
+            <a:off x="526774" y="700000"/>
+            <a:ext cx="10972800" cy="700000"/>
+          </a:xfrm>
+          <a:prstGeom prst="rect">
+            <a:avLst/>
+          </a:prstGeom>
+          <a:noFill/>
+          <a:ln/>
+        </p:spPr>
+        <p:txBody>
+          <a:p>
+            <a:pPr marL="0" indent="0" algn="l">
+              <a:buNone/>
+            </a:pPr>
+            <a:r>
+              <a:rPr lang="en-US" sz="3200" b="1" dirty="0">
+                <a:solidFill>
+                  <a:srgbClr val="FFFFFF"/>
+                </a:solidFill>
+                <a:latin typeface="Arial" pitchFamily="34" charset="0"/>
+                <a:ea typeface="Arial" pitchFamily="34" charset="-122"/>
+              </a:rPr>
+              <a:t>V2X </a:t>
+            </a:r>
+            <a:r>
+              <a:rPr lang="zh-CN" sz="3200" b="1" dirty="0">
+                <a:solidFill>
+                  <a:srgbClr val="1EEF97"/>
+                </a:solidFill>
+                <a:latin typeface="Arial" pitchFamily="34" charset="0"/>
+                <a:ea typeface="Microsoft YaHei" pitchFamily="34" charset="-122"/>
+              </a:rPr>
+              <a:t>赋能</a:t>
+            </a:r>
+            <a:r>
+              <a:rPr lang="zh-CN" sz="3200" b="1" dirty="0">
+                <a:solidFill>
+                  <a:srgbClr val="FFFFFF"/>
+                </a:solidFill>
+                <a:latin typeface="Arial" pitchFamily="34" charset="0"/>
+                <a:ea typeface="Microsoft YaHei" pitchFamily="34" charset="-122"/>
+              </a:rPr>
+              <a:t> C-NCAP 2027 AEB 测试场景</a:t>
+            </a:r>
+          </a:p>
+        </p:txBody>
+      </p:sp>
+      <p:sp>
+        <p:nvSpPr>
+          <p:cNvPr id="7" name="Underline"/>
+          <p:cNvSpPr/>
+          <p:nvPr/>
+        </p:nvSpPr>
+        <p:spPr>
+          <a:xfrm>
+            <a:off x="526774" y="1400000"/>
+            <a:ext cx="2743200" cy="45720"/>
+          </a:xfrm>
+          <a:prstGeom prst="rect">
+            <a:avLst/>
+          </a:prstGeom>
+          <a:solidFill>
+            <a:srgbClr val="1EEF97"/>
+          </a:solidFill>
+          <a:ln/>
+        </p:spPr>
+      </p:sp>
+      <p:sp>
+        <p:nvSpPr>
+          <p:cNvPr id="8" name="Subtitle"/>
+          <p:cNvSpPr/>
+          <p:nvPr/>
+        </p:nvSpPr>
+        <p:spPr>
+          <a:xfrm>
+            <a:off x="526774" y="1500000"/>
+            <a:ext cx="10972800" cy="320040"/>
+          </a:xfrm>
+          <a:prstGeom prst="rect">
+            <a:avLst/>
+          </a:prstGeom>
+          <a:noFill/>
+          <a:ln/>
+        </p:spPr>
+        <p:txBody>
+          <a:p>
+            <a:pPr marL="0" indent="0" algn="l">
+              <a:buNone/>
+            </a:pPr>
+            <a:r>
+              <a:rPr lang="zh-CN" sz="1400" dirty="0">
+                <a:solidFill>
+                  <a:srgbClr val="CDCDD2"/>
+                </a:solidFill>
+                <a:latin typeface="Arial" pitchFamily="34" charset="0"/>
+                <a:ea typeface="Microsoft YaHei" pitchFamily="34" charset="-122"/>
+              </a:rPr>
+              <a:t>V2V 车车直连 | V2P 车与弱势道路使用者 | V2I 车路协同 | 非视距穿透 · 恶劣天气抗扰 · 意图共享</a:t>
+            </a:r>
+          </a:p>
+        </p:txBody>
+      </p:sp>
+      <p:sp>
+        <p:nvSpPr>
+          <p:cNvPr id="9" name="VLine"/>
+          <p:cNvSpPr/>
+          <p:nvPr/>
+        </p:nvSpPr>
+        <p:spPr>
+          <a:xfrm>
+            <a:off x="6131451" y="2050000"/>
+            <a:ext cx="45719" cy="3600000"/>
+          </a:xfrm>
+          <a:prstGeom prst="rect">
+            <a:avLst/>
+          </a:prstGeom>
+          <a:solidFill>
+            <a:srgbClr val="442EE0"/>
+          </a:solidFill>
+          <a:ln/>
+        </p:spPr>
+      </p:sp>
+      <p:sp>
+        <p:nvSpPr>
+          <p:cNvPr id="10" name="LeftHeader"/>
+          <p:cNvSpPr/>
+          <p:nvPr/>
+        </p:nvSpPr>
+        <p:spPr>
+          <a:xfrm>
+            <a:off x="526774" y="2000000"/>
+            <a:ext cx="5100000" cy="320040"/>
+          </a:xfrm>
+          <a:prstGeom prst="rect">
+            <a:avLst/>
+          </a:prstGeom>
+          <a:noFill/>
+          <a:ln/>
+        </p:spPr>
+        <p:txBody>
+          <a:p>
+            <a:pPr marL="0" indent="0" algn="l">
+              <a:buNone/>
+            </a:pPr>
+            <a:r>
+              <a:rPr lang="zh-CN" sz="1100" b="1" dirty="0">
+                <a:solidFill>
+                  <a:srgbClr val="1EEF97"/>
+                </a:solidFill>
+                <a:latin typeface="Arial" pitchFamily="34" charset="0"/>
+                <a:ea typeface="Microsoft YaHei" pitchFamily="34" charset="-122"/>
+              </a:rPr>
+              <a:t>附录P — VRU场景 | V2P / 车与弱势道路使用者</a:t>
+            </a:r>
+          </a:p>
+        </p:txBody>
+      </p:sp>
+      <p:sp>
+        <p:nvSpPr>
+          <p:cNvPr id="11" name="LeftList"/>
+          <p:cNvSpPr/>
+          <p:nvPr/>
+        </p:nvSpPr>
+        <p:spPr>
+          <a:xfrm>
+            <a:off x="526774" y="2350000"/>
+            <a:ext cx="5100000" cy="3800000"/>
+          </a:xfrm>
+          <a:prstGeom prst="rect">
+            <a:avLst/>
+          </a:prstGeom>
+          <a:noFill/>
+          <a:ln/>
+        </p:spPr>
+        <p:txBody>
+          <a:p>
+            <a:pPr marL="0" indent="0" algn="l">
+              <a:buNone/>
+            </a:pPr>
+            <a:r>
+              <a:rPr lang="zh-CN" sz="900" b="1" dirty="0">
+                <a:solidFill>
+                  <a:srgbClr val="1EEF97"/>
+                </a:solidFill>
+                <a:latin typeface="Arial" pitchFamily="34" charset="0"/>
+                <a:ea typeface="Microsoft YaHei" pitchFamily="34" charset="-122"/>
+              </a:rPr>
+              <a:t>V2P 穿透遮挡 — 行人/二轮车感知</a:t>
+            </a:r>
+          </a:p>
+          <a:p>
+            <a:pPr marL="171450" indent="0" algn="l">
+              <a:buNone/>
+            </a:pPr>
+            <a:r>
+              <a:rPr lang="zh-CN" sz="700" dirty="0">
+                <a:solidFill>
+                  <a:srgbClr val="CDCDD2"/>
+                </a:solidFill>
+                <a:latin typeface="Arial" pitchFamily="34" charset="0"/>
+                <a:ea typeface="Microsoft YaHei" pitchFamily="34" charset="-122"/>
+              </a:rPr>
+              <a:t>CPFC-MO 动态遮挡儿童 — 被挡儿童可被V2P提前感知</a:t>
+            </a:r>
+          </a:p>
+          <a:p>
+            <a:pPr marL="171450" indent="0" algn="l">
+              <a:buNone/>
+            </a:pPr>
+            <a:r>
+              <a:rPr lang="zh-CN" sz="700" dirty="0">
+                <a:solidFill>
+                  <a:srgbClr val="CDCDD2"/>
+                </a:solidFill>
+                <a:latin typeface="Arial" pitchFamily="34" charset="0"/>
+                <a:ea typeface="Microsoft YaHei" pitchFamily="34" charset="-122"/>
+              </a:rPr>
+              <a:t>CPNC-AI / CPFC-BI 干扰横穿 — 被遮挡弱势道路使用者</a:t>
+            </a:r>
+          </a:p>
+          <a:p>
+            <a:pPr marL="171450" indent="0" algn="l">
+              <a:buNone/>
+            </a:pPr>
+            <a:r>
+              <a:rPr lang="zh-CN" sz="700" dirty="0">
+                <a:solidFill>
+                  <a:srgbClr val="CDCDD2"/>
+                </a:solidFill>
+                <a:latin typeface="Arial" pitchFamily="34" charset="0"/>
+                <a:ea typeface="Microsoft YaHei" pitchFamily="34" charset="-122"/>
+              </a:rPr>
+              <a:t>CBOFA / CBFA-MO 遮挡斜穿 — 穿透车辆障碍物</a:t>
+            </a:r>
+          </a:p>
+          <a:p>
+            <a:pPr marL="171450" indent="0" algn="l">
+              <a:buNone/>
+            </a:pPr>
+            <a:r>
+              <a:rPr lang="zh-CN" sz="700" dirty="0">
+                <a:solidFill>
+                  <a:srgbClr val="CDCDD2"/>
+                </a:solidFill>
+                <a:latin typeface="Arial" pitchFamily="34" charset="0"/>
+                <a:ea typeface="Microsoft YaHei" pitchFamily="34" charset="-122"/>
+              </a:rPr>
+              <a:t>CBNA-AI / CSFA-BI 干扰近端 — V2P弥补传感器盲区</a:t>
+            </a:r>
+          </a:p>
+          <a:p>
+            <a:pPr marL="171450" indent="0" algn="l">
+              <a:buNone/>
+            </a:pPr>
+            <a:r>
+              <a:rPr lang="zh-CN" sz="700" dirty="0">
+                <a:solidFill>
+                  <a:srgbClr val="CDCDD2"/>
+                </a:solidFill>
+                <a:latin typeface="Arial" pitchFamily="34" charset="0"/>
+                <a:ea typeface="Microsoft YaHei" pitchFamily="34" charset="-122"/>
+              </a:rPr>
+              <a:t>CSTAO-RN 右转遮挡 — 路侧V2I+车端V2P协同</a:t>
+            </a:r>
+          </a:p>
+          <a:p>
+            <a:pPr marL="0" indent="0" algn="l">
+              <a:buNone/>
+            </a:pPr>
+            <a:endParaRPr lang="zh-CN" sz="300" dirty="0"/>
+          </a:p>
+          <a:p>
+            <a:pPr marL="0" indent="0" algn="l">
+              <a:buNone/>
+            </a:pPr>
+            <a:r>
+              <a:rPr lang="zh-CN" sz="900" b="1" dirty="0">
+                <a:solidFill>
+                  <a:srgbClr val="1EEF97"/>
+                </a:solidFill>
+                <a:latin typeface="Arial" pitchFamily="34" charset="0"/>
+                <a:ea typeface="Microsoft YaHei" pitchFamily="34" charset="-122"/>
+              </a:rPr>
+              <a:t>V2P 转弯/横穿预警</a:t>
+            </a:r>
+          </a:p>
+          <a:p>
+            <a:pPr marL="171450" indent="0" algn="l">
+              <a:buNone/>
+            </a:pPr>
+            <a:r>
+              <a:rPr lang="zh-CN" sz="700" dirty="0">
+                <a:solidFill>
+                  <a:srgbClr val="CDCDD2"/>
+                </a:solidFill>
+                <a:latin typeface="Arial" pitchFamily="34" charset="0"/>
+                <a:ea typeface="Microsoft YaHei" pitchFamily="34" charset="-122"/>
+              </a:rPr>
+              <a:t>CPTA-LF / CPTA-RF 转弯横穿行人 — 提前感知意图</a:t>
+            </a:r>
+          </a:p>
+          <a:p>
+            <a:pPr marL="171450" indent="0" algn="l">
+              <a:buNone/>
+            </a:pPr>
+            <a:r>
+              <a:rPr lang="zh-CN" sz="700" dirty="0">
+                <a:solidFill>
+                  <a:srgbClr val="CDCDD2"/>
+                </a:solidFill>
+                <a:latin typeface="Arial" pitchFamily="34" charset="0"/>
+                <a:ea typeface="Microsoft YaHei" pitchFamily="34" charset="-122"/>
+              </a:rPr>
+              <a:t>C2S RCPf / C2B RCPn 转弯横穿二轮 — 路口盲区</a:t>
+            </a:r>
+          </a:p>
+          <a:p>
+            <a:pPr marL="171450" indent="0" algn="l">
+              <a:buNone/>
+            </a:pPr>
+            <a:r>
+              <a:rPr lang="zh-CN" sz="700" dirty="0">
+                <a:solidFill>
+                  <a:srgbClr val="CDCDD2"/>
+                </a:solidFill>
+                <a:latin typeface="Arial" pitchFamily="34" charset="0"/>
+                <a:ea typeface="Microsoft YaHei" pitchFamily="34" charset="-122"/>
+              </a:rPr>
+              <a:t>CBLAt 转弯切入 / CBLAc 变道切入 — 意图共享</a:t>
+            </a:r>
+          </a:p>
+          <a:p>
+            <a:pPr marL="171450" indent="0" algn="l">
+              <a:buNone/>
+            </a:pPr>
+            <a:r>
+              <a:rPr lang="zh-CN" sz="700" dirty="0">
+                <a:solidFill>
+                  <a:srgbClr val="CDCDD2"/>
+                </a:solidFill>
+                <a:latin typeface="Arial" pitchFamily="34" charset="0"/>
+                <a:ea typeface="Microsoft YaHei" pitchFamily="34" charset="-122"/>
+              </a:rPr>
+              <a:t>CSFhol 直行对向二轮 — 远距离V2P预警</a:t>
+            </a:r>
+          </a:p>
+          <a:p>
+            <a:pPr marL="0" indent="0" algn="l">
+              <a:buNone/>
+            </a:pPr>
+            <a:endParaRPr lang="zh-CN" sz="300" dirty="0"/>
+          </a:p>
+          <a:p>
+            <a:pPr marL="0" indent="0" algn="l">
+              <a:buNone/>
+            </a:pPr>
+            <a:r>
+              <a:rPr lang="zh-CN" sz="900" b="1" dirty="0">
+                <a:solidFill>
+                  <a:srgbClr val="CDCDD2"/>
+                </a:solidFill>
+                <a:latin typeface="Arial" pitchFamily="34" charset="0"/>
+                <a:ea typeface="Microsoft YaHei" pitchFamily="34" charset="-122"/>
+              </a:rPr>
+              <a:t>恶劣环境 — 天气/光照不敏感</a:t>
+            </a:r>
+          </a:p>
+          <a:p>
+            <a:pPr marL="171450" indent="0" algn="l">
+              <a:buNone/>
+            </a:pPr>
+            <a:r>
+              <a:rPr lang="zh-CN" sz="700" dirty="0">
+                <a:solidFill>
+                  <a:srgbClr val="CDCDD2"/>
+                </a:solidFill>
+                <a:latin typeface="Arial" pitchFamily="34" charset="0"/>
+                <a:ea typeface="Microsoft YaHei" pitchFamily="34" charset="-122"/>
+              </a:rPr>
+              <a:t>CPFAr 雨天远端横穿 — 摄像头受限，V2X不受影响</a:t>
+            </a:r>
+          </a:p>
+          <a:p>
+            <a:pPr marL="171450" indent="0" algn="l">
+              <a:buNone/>
+            </a:pPr>
+            <a:r>
+              <a:rPr lang="zh-CN" sz="700" dirty="0">
+                <a:solidFill>
+                  <a:srgbClr val="CDCDD2"/>
+                </a:solidFill>
+                <a:latin typeface="Arial" pitchFamily="34" charset="0"/>
+                <a:ea typeface="Microsoft YaHei" pitchFamily="34" charset="-122"/>
+              </a:rPr>
+              <a:t>CBLAb 电动自行车夜间 — 弱光下V2P优于视觉</a:t>
+            </a:r>
+          </a:p>
+          <a:p>
+            <a:pPr marL="171450" indent="0" algn="l">
+              <a:buNone/>
+            </a:pPr>
+            <a:r>
+              <a:rPr lang="zh-CN" sz="700" dirty="0">
+                <a:solidFill>
+                  <a:srgbClr val="CDCDD2"/>
+                </a:solidFill>
+                <a:latin typeface="Arial" pitchFamily="34" charset="0"/>
+                <a:ea typeface="Microsoft YaHei" pitchFamily="34" charset="-122"/>
+              </a:rPr>
+              <a:t>CPFAh / CPLAh 高速场景 — 远距离V2P提前预警</a:t>
+            </a:r>
+          </a:p>
+        </p:txBody>
+      </p:sp>
+      <p:sp>
+        <p:nvSpPr>
+          <p:cNvPr id="20" name="RightHeader"/>
+          <p:cNvSpPr/>
+          <p:nvPr/>
+        </p:nvSpPr>
+        <p:spPr>
+          <a:xfrm>
+            <a:off x="6636028" y="2000000"/>
+            <a:ext cx="5100000" cy="320040"/>
+          </a:xfrm>
+          <a:prstGeom prst="rect">
+            <a:avLst/>
+          </a:prstGeom>
+          <a:noFill/>
+          <a:ln/>
+        </p:spPr>
+        <p:txBody>
+          <a:p>
+            <a:pPr marL="0" indent="0" algn="l">
+              <a:buNone/>
+            </a:pPr>
+            <a:r>
+              <a:rPr lang="zh-CN" sz="1100" b="1" dirty="0">
+                <a:solidFill>
+                  <a:srgbClr val="1EEF97"/>
+                </a:solidFill>
+                <a:latin typeface="Arial" pitchFamily="34" charset="0"/>
+                <a:ea typeface="Microsoft YaHei" pitchFamily="34" charset="-122"/>
+              </a:rPr>
+              <a:t>附录Q — C2C场景 | V2V / V2I 车车与车路协同</a:t>
+            </a:r>
+          </a:p>
+        </p:txBody>
+      </p:sp>
+      <p:sp>
+        <p:nvSpPr>
+          <p:cNvPr id="21" name="RightList"/>
+          <p:cNvSpPr/>
+          <p:nvPr/>
+        </p:nvSpPr>
+        <p:spPr>
+          <a:xfrm>
+            <a:off x="6636028" y="2350000"/>
+            <a:ext cx="5100000" cy="3800000"/>
+          </a:xfrm>
+          <a:prstGeom prst="rect">
+            <a:avLst/>
+          </a:prstGeom>
+          <a:noFill/>
+          <a:ln/>
+        </p:spPr>
+        <p:txBody>
+          <a:p>
+            <a:pPr marL="0" indent="0" algn="l">
+              <a:buNone/>
+            </a:pPr>
+            <a:r>
+              <a:rPr lang="zh-CN" sz="900" b="1" dirty="0">
+                <a:solidFill>
+                  <a:srgbClr val="1EEF97"/>
+                </a:solidFill>
+                <a:latin typeface="Arial" pitchFamily="34" charset="0"/>
+                <a:ea typeface="Microsoft YaHei" pitchFamily="34" charset="-122"/>
+              </a:rPr>
+              <a:t>V2V 遮挡/非视距 — 穿透障碍感知</a:t>
+            </a:r>
+          </a:p>
+          <a:p>
+            <a:pPr marL="171450" indent="0" algn="l">
+              <a:buNone/>
+            </a:pPr>
+            <a:r>
+              <a:rPr lang="zh-CN" sz="700" dirty="0">
+                <a:solidFill>
+                  <a:srgbClr val="CDCDD2"/>
+                </a:solidFill>
+                <a:latin typeface="Arial" pitchFamily="34" charset="0"/>
+                <a:ea typeface="Microsoft YaHei" pitchFamily="34" charset="-122"/>
+              </a:rPr>
+              <a:t>C2C SCPmo 动态遮挡横穿 — 被挡车辆V2V预警</a:t>
+            </a:r>
+          </a:p>
+          <a:p>
+            <a:pPr marL="171450" indent="0" algn="l">
+              <a:buNone/>
+            </a:pPr>
+            <a:r>
+              <a:rPr lang="zh-CN" sz="700" dirty="0">
+                <a:solidFill>
+                  <a:srgbClr val="CDCDD2"/>
+                </a:solidFill>
+                <a:latin typeface="Arial" pitchFamily="34" charset="0"/>
+                <a:ea typeface="Microsoft YaHei" pitchFamily="34" charset="-122"/>
+              </a:rPr>
+              <a:t>C2C SCPso 静态遮挡横穿 — 越过建筑物感知</a:t>
+            </a:r>
+          </a:p>
+          <a:p>
+            <a:pPr marL="171450" indent="0" algn="l">
+              <a:buNone/>
+            </a:pPr>
+            <a:r>
+              <a:rPr lang="zh-CN" sz="700" dirty="0">
+                <a:solidFill>
+                  <a:srgbClr val="CDCDD2"/>
+                </a:solidFill>
+                <a:latin typeface="Arial" pitchFamily="34" charset="0"/>
+                <a:ea typeface="Microsoft YaHei" pitchFamily="34" charset="-122"/>
+              </a:rPr>
+              <a:t>CCFT / CCFTf 转弯对撞 — 路口建筑遮挡，V2V直连</a:t>
+            </a:r>
+          </a:p>
+          <a:p>
+            <a:pPr marL="171450" indent="0" algn="l">
+              <a:buNone/>
+            </a:pPr>
+            <a:r>
+              <a:rPr lang="zh-CN" sz="700" dirty="0">
+                <a:solidFill>
+                  <a:srgbClr val="CDCDD2"/>
+                </a:solidFill>
+                <a:latin typeface="Arial" pitchFamily="34" charset="0"/>
+                <a:ea typeface="Microsoft YaHei" pitchFamily="34" charset="-122"/>
+              </a:rPr>
+              <a:t>LCPf / LCPn 左转横穿 — 对向遮挡车辆提前通信</a:t>
+            </a:r>
+          </a:p>
+          <a:p>
+            <a:pPr marL="0" indent="0" algn="l">
+              <a:buNone/>
+            </a:pPr>
+            <a:endParaRPr lang="zh-CN" sz="300" dirty="0"/>
+          </a:p>
+          <a:p>
+            <a:pPr marL="0" indent="0" algn="l">
+              <a:buNone/>
+            </a:pPr>
+            <a:r>
+              <a:rPr lang="zh-CN" sz="900" b="1" dirty="0">
+                <a:solidFill>
+                  <a:srgbClr val="1EEF97"/>
+                </a:solidFill>
+                <a:latin typeface="Arial" pitchFamily="34" charset="0"/>
+                <a:ea typeface="Microsoft YaHei" pitchFamily="34" charset="-122"/>
+              </a:rPr>
+              <a:t>V2V 恶劣天气 — 传感器降级补偿</a:t>
+            </a:r>
+          </a:p>
+          <a:p>
+            <a:pPr marL="171450" indent="0" algn="l">
+              <a:buNone/>
+            </a:pPr>
+            <a:r>
+              <a:rPr lang="zh-CN" sz="700" dirty="0">
+                <a:solidFill>
+                  <a:srgbClr val="CDCDD2"/>
+                </a:solidFill>
+                <a:latin typeface="Arial" pitchFamily="34" charset="0"/>
+                <a:ea typeface="Microsoft YaHei" pitchFamily="34" charset="-122"/>
+              </a:rPr>
+              <a:t>CCRsr 雨天追尾 — 雷达/摄像头衰减，V2V不受影响</a:t>
+            </a:r>
+          </a:p>
+          <a:p>
+            <a:pPr marL="171450" indent="0" algn="l">
+              <a:buNone/>
+            </a:pPr>
+            <a:r>
+              <a:rPr lang="zh-CN" sz="700" dirty="0">
+                <a:solidFill>
+                  <a:srgbClr val="CDCDD2"/>
+                </a:solidFill>
+                <a:latin typeface="Arial" pitchFamily="34" charset="0"/>
+                <a:ea typeface="Microsoft YaHei" pitchFamily="34" charset="-122"/>
+              </a:rPr>
+              <a:t>CCRsf 雾天追尾 — 能见度极低，V2V稳定通信</a:t>
+            </a:r>
+          </a:p>
+          <a:p>
+            <a:pPr marL="171450" indent="0" algn="l">
+              <a:buNone/>
+            </a:pPr>
+            <a:r>
+              <a:rPr lang="zh-CN" sz="700" dirty="0">
+                <a:solidFill>
+                  <a:srgbClr val="CDCDD2"/>
+                </a:solidFill>
+                <a:latin typeface="Arial" pitchFamily="34" charset="0"/>
+                <a:ea typeface="Microsoft YaHei" pitchFamily="34" charset="-122"/>
+              </a:rPr>
+              <a:t>CCFhos 直行对撞 — 雨雾天远距离V2V预警</a:t>
+            </a:r>
+          </a:p>
+          <a:p>
+            <a:pPr marL="0" indent="0" algn="l">
+              <a:buNone/>
+            </a:pPr>
+            <a:endParaRPr lang="zh-CN" sz="300" dirty="0"/>
+          </a:p>
+          <a:p>
+            <a:pPr marL="0" indent="0" algn="l">
+              <a:buNone/>
+            </a:pPr>
+            <a:r>
+              <a:rPr lang="zh-CN" sz="900" b="1" dirty="0">
+                <a:solidFill>
+                  <a:srgbClr val="CDCDD2"/>
+                </a:solidFill>
+                <a:latin typeface="Arial" pitchFamily="34" charset="0"/>
+                <a:ea typeface="Microsoft YaHei" pitchFamily="34" charset="-122"/>
+              </a:rPr>
+              <a:t>V2V 意图共享 — 切入/制动预警</a:t>
+            </a:r>
+          </a:p>
+          <a:p>
+            <a:pPr marL="171450" indent="0" algn="l">
+              <a:buNone/>
+            </a:pPr>
+            <a:r>
+              <a:rPr lang="zh-CN" sz="700" dirty="0">
+                <a:solidFill>
+                  <a:srgbClr val="CDCDD2"/>
+                </a:solidFill>
+                <a:latin typeface="Arial" pitchFamily="34" charset="0"/>
+                <a:ea typeface="Microsoft YaHei" pitchFamily="34" charset="-122"/>
+              </a:rPr>
+              <a:t>CCRc 切入追尾 — 邻车变道意图实时共享</a:t>
+            </a:r>
+          </a:p>
+          <a:p>
+            <a:pPr marL="171450" indent="0" algn="l">
+              <a:buNone/>
+            </a:pPr>
+            <a:r>
+              <a:rPr lang="zh-CN" sz="700" dirty="0">
+                <a:solidFill>
+                  <a:srgbClr val="CDCDD2"/>
+                </a:solidFill>
+                <a:latin typeface="Arial" pitchFamily="34" charset="0"/>
+                <a:ea typeface="Microsoft YaHei" pitchFamily="34" charset="-122"/>
+              </a:rPr>
+              <a:t>CCRb 制动追尾 — 前车制动信号低延迟广播</a:t>
+            </a:r>
+          </a:p>
+          <a:p>
+            <a:pPr marL="171450" indent="0" algn="l">
+              <a:buNone/>
+            </a:pPr>
+            <a:r>
+              <a:rPr lang="zh-CN" sz="700" dirty="0">
+                <a:solidFill>
+                  <a:srgbClr val="CDCDD2"/>
+                </a:solidFill>
+                <a:latin typeface="Arial" pitchFamily="34" charset="0"/>
+                <a:ea typeface="Microsoft YaHei" pitchFamily="34" charset="-122"/>
+              </a:rPr>
+              <a:t>CCRh 高速追尾 / CCRbc 弯道制动 — 超视距补盲</a:t>
+            </a:r>
+          </a:p>
+          <a:p>
+            <a:pPr marL="171450" indent="0" algn="l">
+              <a:buNone/>
+            </a:pPr>
+            <a:r>
+              <a:rPr lang="zh-CN" sz="700" dirty="0">
+                <a:solidFill>
+                  <a:srgbClr val="CDCDD2"/>
+                </a:solidFill>
+                <a:latin typeface="Arial" pitchFamily="34" charset="0"/>
+                <a:ea typeface="Microsoft YaHei" pitchFamily="34" charset="-122"/>
+              </a:rPr>
+              <a:t>RCPf 右转横穿 — 转向意图+位置共享</a:t>
+            </a:r>
+          </a:p>
+          <a:p>
+            <a:pPr marL="0" indent="0" algn="l">
+              <a:buNone/>
+            </a:pPr>
+            <a:endParaRPr lang="zh-CN" sz="300" dirty="0"/>
+          </a:p>
+          <a:p>
+            <a:pPr marL="0" indent="0" algn="l">
+              <a:buNone/>
+            </a:pPr>
+            <a:r>
+              <a:rPr lang="zh-CN" sz="900" b="1" dirty="0">
+                <a:solidFill>
+                  <a:srgbClr val="CDCDD2"/>
+                </a:solidFill>
+                <a:latin typeface="Arial" pitchFamily="34" charset="0"/>
+                <a:ea typeface="Microsoft YaHei" pitchFamily="34" charset="-122"/>
+              </a:rPr>
+              <a:t>V2I 路侧协同</a:t>
+            </a:r>
+          </a:p>
+          <a:p>
+            <a:pPr marL="171450" indent="0" algn="l">
+              <a:buNone/>
+            </a:pPr>
+            <a:r>
+              <a:rPr lang="zh-CN" sz="700" dirty="0">
+                <a:solidFill>
+                  <a:srgbClr val="CDCDD2"/>
+                </a:solidFill>
+                <a:latin typeface="Arial" pitchFamily="34" charset="0"/>
+                <a:ea typeface="Microsoft YaHei" pitchFamily="34" charset="-122"/>
+              </a:rPr>
+              <a:t>全部路口转弯/横穿场景可通过V2I路侧单元(RSU)</a:t>
+            </a:r>
+          </a:p>
+          <a:p>
+            <a:pPr marL="171450" indent="0" algn="l">
+              <a:buNone/>
+            </a:pPr>
+            <a:r>
+              <a:rPr lang="zh-CN" sz="700" dirty="0">
+                <a:solidFill>
+                  <a:srgbClr val="CDCDD2"/>
+                </a:solidFill>
+                <a:latin typeface="Arial" pitchFamily="34" charset="0"/>
+                <a:ea typeface="Microsoft YaHei" pitchFamily="34" charset="-122"/>
+              </a:rPr>
+              <a:t>获取路口全局目标列表，弥补单车感知盲区</a:t>
+            </a:r>
+          </a:p>
+          <a:p>
+            <a:pPr marL="171450" indent="0" algn="l">
+              <a:buNone/>
+            </a:pPr>
+            <a:r>
+              <a:rPr lang="zh-CN" sz="700" dirty="0">
+                <a:solidFill>
+                  <a:srgbClr val="CDCDD2"/>
+                </a:solidFill>
+                <a:latin typeface="Arial" pitchFamily="34" charset="0"/>
+                <a:ea typeface="Microsoft YaHei" pitchFamily="34" charset="-122"/>
+              </a:rPr>
+              <a:t>典型: CPTA系列 / CCFT系列 / C2C LCP&amp;SCP系列</a:t>
+            </a:r>
+          </a:p>
+        </p:txBody>
+      </p:sp>
+      <p:sp>
+        <p:nvSpPr>
+          <p:cNvPr id="90" name="BtmLine"/>
+          <p:cNvSpPr/>
+          <p:nvPr/>
+        </p:nvSpPr>
+        <p:spPr>
+          <a:xfrm>
+            <a:off x="526774" y="5875616"/>
+            <a:ext cx="11064240" cy="10973"/>
+          </a:xfrm>
+          <a:prstGeom prst="rect">
+            <a:avLst/>
+          </a:prstGeom>
+          <a:solidFill>
+            <a:srgbClr val="373741"/>
+          </a:solidFill>
+          <a:ln/>
+        </p:spPr>
+      </p:sp>
+      <p:sp>
+        <p:nvSpPr>
+          <p:cNvPr id="91" name="Stat1"/>
+          <p:cNvSpPr/>
+          <p:nvPr/>
+        </p:nvSpPr>
+        <p:spPr>
+          <a:xfrm>
+            <a:off x="526774" y="5967056"/>
+            <a:ext cx="2743200" cy="292608"/>
+          </a:xfrm>
+          <a:prstGeom prst="rect">
+            <a:avLst/>
+          </a:prstGeom>
+          <a:noFill/>
+          <a:ln/>
+        </p:spPr>
+        <p:txBody>
+          <a:p>
+            <a:pPr marL="0" indent="0" algn="l">
+              <a:buNone/>
+            </a:pPr>
+            <a:r>
+              <a:rPr lang="en-US" sz="1600" b="1" dirty="0">
+                <a:solidFill>
+                  <a:srgbClr val="1EEF97"/>
+                </a:solidFill>
+                <a:latin typeface="Arial" pitchFamily="34" charset="0"/>
+                <a:ea typeface="Microsoft YaHei" pitchFamily="34" charset="-122"/>
+              </a:rPr>
+              <a:t>~70%</a:t>
+            </a:r>
+          </a:p>
+        </p:txBody>
+      </p:sp>
+      <p:sp>
+        <p:nvSpPr>
+          <p:cNvPr id="92" name="Stat1Label"/>
+          <p:cNvSpPr/>
+          <p:nvPr/>
+        </p:nvSpPr>
+        <p:spPr>
+          <a:xfrm>
+            <a:off x="526774" y="6213944"/>
+            <a:ext cx="2743200" cy="182880"/>
+          </a:xfrm>
+          <a:prstGeom prst="rect">
+            <a:avLst/>
+          </a:prstGeom>
+          <a:noFill/>
+          <a:ln/>
+        </p:spPr>
+        <p:txBody>
+          <a:p>
+            <a:pPr marL="0" indent="0" algn="l">
+              <a:buNone/>
+            </a:pPr>
+            <a:r>
+              <a:rPr lang="zh-CN" sz="800" dirty="0">
+                <a:solidFill>
+                  <a:srgbClr val="CDCDD2"/>
+                </a:solidFill>
+                <a:latin typeface="Arial" pitchFamily="34" charset="0"/>
+                <a:ea typeface="Microsoft YaHei" pitchFamily="34" charset="-122"/>
+              </a:rPr>
+              <a:t>场景可由V2X增强</a:t>
+            </a:r>
+          </a:p>
+        </p:txBody>
+      </p:sp>
+      <p:sp>
+        <p:nvSpPr>
+          <p:cNvPr id="93" name="Stat2"/>
+          <p:cNvSpPr/>
+          <p:nvPr/>
+        </p:nvSpPr>
+        <p:spPr>
+          <a:xfrm>
+            <a:off x="3292834" y="5967056"/>
+            <a:ext cx="2743200" cy="292608"/>
+          </a:xfrm>
+          <a:prstGeom prst="rect">
+            <a:avLst/>
+          </a:prstGeom>
+          <a:noFill/>
+          <a:ln/>
+        </p:spPr>
+        <p:txBody>
+          <a:p>
+            <a:pPr marL="0" indent="0" algn="l">
+              <a:buNone/>
+            </a:pPr>
+            <a:r>
+              <a:rPr lang="en-US" sz="1600" b="1" dirty="0">
+                <a:solidFill>
+                  <a:srgbClr val="1EEF97"/>
+                </a:solidFill>
+                <a:latin typeface="Arial" pitchFamily="34" charset="0"/>
+                <a:ea typeface="Microsoft YaHei" pitchFamily="34" charset="-122"/>
+              </a:rPr>
+              <a:t>V2V+P+I</a:t>
+            </a:r>
+          </a:p>
+        </p:txBody>
+      </p:sp>
+      <p:sp>
+        <p:nvSpPr>
+          <p:cNvPr id="94" name="Stat2Label"/>
+          <p:cNvSpPr/>
+          <p:nvPr/>
+        </p:nvSpPr>
+        <p:spPr>
+          <a:xfrm>
+            <a:off x="3292834" y="6213944"/>
+            <a:ext cx="2743200" cy="182880"/>
+          </a:xfrm>
+          <a:prstGeom prst="rect">
+            <a:avLst/>
+          </a:prstGeom>
+          <a:noFill/>
+          <a:ln/>
+        </p:spPr>
+        <p:txBody>
+          <a:p>
+            <a:pPr marL="0" indent="0" algn="l">
+              <a:buNone/>
+            </a:pPr>
+            <a:r>
+              <a:rPr lang="zh-CN" sz="800" dirty="0">
+                <a:solidFill>
+                  <a:srgbClr val="CDCDD2"/>
+                </a:solidFill>
+                <a:latin typeface="Arial" pitchFamily="34" charset="0"/>
+                <a:ea typeface="Microsoft YaHei" pitchFamily="34" charset="-122"/>
+              </a:rPr>
+              <a:t>V2X通信模式协同</a:t>
+            </a:r>
+          </a:p>
+        </p:txBody>
+      </p:sp>
+      <p:sp>
+        <p:nvSpPr>
+          <p:cNvPr id="95" name="Stat3"/>
+          <p:cNvSpPr/>
+          <p:nvPr/>
+        </p:nvSpPr>
+        <p:spPr>
+          <a:xfrm>
+            <a:off x="6357863" y="5967056"/>
+            <a:ext cx="2743200" cy="292608"/>
+          </a:xfrm>
+          <a:prstGeom prst="rect">
+            <a:avLst/>
+          </a:prstGeom>
+          <a:noFill/>
+          <a:ln/>
+        </p:spPr>
+        <p:txBody>
+          <a:p>
+            <a:pPr marL="0" indent="0" algn="l">
+              <a:buNone/>
+            </a:pPr>
+            <a:r>
+              <a:rPr lang="en-US" sz="1600" b="1" dirty="0">
+                <a:solidFill>
+                  <a:srgbClr val="1EEF97"/>
+                </a:solidFill>
+                <a:latin typeface="Arial" pitchFamily="34" charset="0"/>
+                <a:ea typeface="Microsoft YaHei" pitchFamily="34" charset="-122"/>
+              </a:rPr>
+              <a:t>NLOS</a:t>
+            </a:r>
+          </a:p>
+        </p:txBody>
+      </p:sp>
+      <p:sp>
+        <p:nvSpPr>
+          <p:cNvPr id="96" name="Stat3Label"/>
+          <p:cNvSpPr/>
+          <p:nvPr/>
+        </p:nvSpPr>
+        <p:spPr>
+          <a:xfrm>
+            <a:off x="6357863" y="6191680"/>
+            <a:ext cx="2743200" cy="182880"/>
+          </a:xfrm>
+          <a:prstGeom prst="rect">
+            <a:avLst/>
+          </a:prstGeom>
+          <a:noFill/>
+          <a:ln/>
+        </p:spPr>
+        <p:txBody>
+          <a:p>
+            <a:pPr marL="0" indent="0" algn="l">
+              <a:buNone/>
+            </a:pPr>
+            <a:r>
+              <a:rPr lang="zh-CN" sz="800" dirty="0">
+                <a:solidFill>
+                  <a:srgbClr val="CDCDD2"/>
+                </a:solidFill>
+                <a:latin typeface="Arial" pitchFamily="34" charset="0"/>
+                <a:ea typeface="Microsoft YaHei" pitchFamily="34" charset="-122"/>
+              </a:rPr>
+              <a:t>非视距穿透是核心优势</a:t>
+            </a:r>
+          </a:p>
+        </p:txBody>
+      </p:sp>
+      <p:sp>
+        <p:nvSpPr>
+          <p:cNvPr id="97" name="Stat4"/>
+          <p:cNvSpPr/>
+          <p:nvPr/>
+        </p:nvSpPr>
+        <p:spPr>
+          <a:xfrm>
+            <a:off x="9123923" y="5967056"/>
+            <a:ext cx="2743200" cy="292608"/>
+          </a:xfrm>
+          <a:prstGeom prst="rect">
+            <a:avLst/>
+          </a:prstGeom>
+          <a:noFill/>
+          <a:ln/>
+        </p:spPr>
+        <p:txBody>
+          <a:p>
+            <a:pPr marL="0" indent="0" algn="l">
+              <a:buNone/>
+            </a:pPr>
+            <a:r>
+              <a:rPr lang="en-US" sz="1600" b="1" dirty="0">
+                <a:solidFill>
+                  <a:srgbClr val="1EEF97"/>
+                </a:solidFill>
+                <a:latin typeface="Arial" pitchFamily="34" charset="0"/>
+                <a:ea typeface="Microsoft YaHei" pitchFamily="34" charset="-122"/>
+              </a:rPr>
+              <a:t>全天候</a:t>
+            </a:r>
+          </a:p>
+        </p:txBody>
+      </p:sp>
+      <p:sp>
+        <p:nvSpPr>
+          <p:cNvPr id="98" name="Stat4Label"/>
+          <p:cNvSpPr/>
+          <p:nvPr/>
+        </p:nvSpPr>
+        <p:spPr>
+          <a:xfrm>
+            <a:off x="9123923" y="6191680"/>
+            <a:ext cx="2743200" cy="182880"/>
+          </a:xfrm>
+          <a:prstGeom prst="rect">
+            <a:avLst/>
+          </a:prstGeom>
+          <a:noFill/>
+          <a:ln/>
+        </p:spPr>
+        <p:txBody>
+          <a:p>
+            <a:pPr marL="0" indent="0" algn="l">
+              <a:buNone/>
+            </a:pPr>
+            <a:r>
+              <a:rPr lang="zh-CN" sz="800" dirty="0">
+                <a:solidFill>
+                  <a:srgbClr val="CDCDD2"/>
+                </a:solidFill>
+                <a:latin typeface="Arial" pitchFamily="34" charset="0"/>
+                <a:ea typeface="Microsoft YaHei" pitchFamily="34" charset="-122"/>
+              </a:rPr>
+              <a:t>雨雾夜不受影响</a:t>
+            </a:r>
+          </a:p>
+        </p:txBody>
+      </p:sp>
+      <p:sp>
+        <p:nvSpPr>
+          <p:cNvPr id="99" name="Footer"/>
+          <p:cNvSpPr/>
+          <p:nvPr/>
+        </p:nvSpPr>
+        <p:spPr>
+          <a:xfrm>
+            <a:off x="526774" y="6450000"/>
+            <a:ext cx="4572000" cy="137160"/>
+          </a:xfrm>
+          <a:prstGeom prst="rect">
+            <a:avLst/>
+          </a:prstGeom>
+          <a:noFill/>
+          <a:ln/>
+        </p:spPr>
+        <p:txBody>
+          <a:p>
+            <a:pPr marL="0" indent="0" algn="l">
+              <a:buNone/>
+            </a:pPr>
+            <a:r>
+              <a:rPr lang="zh-CN" sz="700" dirty="0">
+                <a:solidFill>
+                  <a:srgbClr val="888888"/>
+                </a:solidFill>
+                <a:latin typeface="Arial" pitchFamily="34" charset="0"/>
+                <a:ea typeface="Microsoft YaHei" pitchFamily="34" charset="-122"/>
+              </a:rPr>
+              <a:t>INTERNAL / CONFIDENTIAL  |  CSD class: 2.5  |  基于 C-NCAP 2027 场景的 V2X 赋能分析</a:t>
+            </a:r>
+          </a:p>
+        </p:txBody>
+      </p:sp>
     </p:spTree>
   </p:cSld>
-  <p:clrMapOvr><a:masterClrMapping/></p:clrMapOvr>
+  <p:clrMapOvr>
+    <a:masterClrMapping/>
+  </p:clrMapOvr>
 </p:sld>
 </file>
 

</xml_diff>

<commit_message>
Correct V2X slide: only document-specified scenarios
- Remove theoretical V2X analysis, use only C-NCAP document references
- Appendix P: no V2X/C-V2X mentions in any VRU scenario
- Appendix Q: only CCRh, CCFhos, C2C SCPso explicitly reference C-V2X
- GVT (Global Vehicle Target) supports C-V2X direct communication
- Source: Q.3.6.1.2.4 / Q.3.6.1.7.11.5

Co-Authored-By: Claude Opus 4.7 <noreply@anthropic.com>
</commit_message>
<xml_diff>
--- a/AEB_Introduction.pptx
+++ b/AEB_Introduction.pptx
@@ -4389,7 +4389,7 @@
 
 <file path=ppt/slides/slide3.xml><?xml version="1.0" encoding="utf-8"?>
 <p:sld xmlns:a="http://schemas.openxmlformats.org/drawingml/2006/main" xmlns:r="http://schemas.openxmlformats.org/officeDocument/2006/relationships" xmlns:p="http://schemas.openxmlformats.org/presentationml/2006/main">
-  <p:cSld name="Slide 3 - V2X">
+  <p:cSld name="Slide 3 - V2X in C-NCAP 2027">
     <p:bg>
       <p:bgPr>
         <a:solidFill>
@@ -4532,14 +4532,14 @@
               <a:buNone/>
             </a:pPr>
             <a:r>
-              <a:rPr lang="en-US" sz="3200" b="1" dirty="0">
+              <a:rPr lang="zh-CN" sz="3200" b="1" dirty="0">
                 <a:solidFill>
                   <a:srgbClr val="FFFFFF"/>
                 </a:solidFill>
                 <a:latin typeface="Arial" pitchFamily="34" charset="0"/>
-                <a:ea typeface="Arial" pitchFamily="34" charset="-122"/>
-              </a:rPr>
-              <a:t>V2X </a:t>
+                <a:ea typeface="Microsoft YaHei" pitchFamily="34" charset="-122"/>
+              </a:rPr>
+              <a:t>C-NCAP 2027 AEB 场景中的 </a:t>
             </a:r>
             <a:r>
               <a:rPr lang="zh-CN" sz="3200" b="1" dirty="0">
@@ -4549,7 +4549,7 @@
                 <a:latin typeface="Arial" pitchFamily="34" charset="0"/>
                 <a:ea typeface="Microsoft YaHei" pitchFamily="34" charset="-122"/>
               </a:rPr>
-              <a:t>赋能</a:t>
+              <a:t>V2X / C-V2X</a:t>
             </a:r>
             <a:r>
               <a:rPr lang="zh-CN" sz="3200" b="1" dirty="0">
@@ -4559,7 +4559,7 @@
                 <a:latin typeface="Arial" pitchFamily="34" charset="0"/>
                 <a:ea typeface="Microsoft YaHei" pitchFamily="34" charset="-122"/>
               </a:rPr>
-              <a:t> C-NCAP 2027 AEB 测试场景</a:t>
+              <a:t> 技术</a:t>
             </a:r>
           </a:p>
         </p:txBody>
@@ -4607,14 +4607,14 @@
               <a:buNone/>
             </a:pPr>
             <a:r>
-              <a:rPr lang="zh-CN" sz="1400" dirty="0">
+              <a:rPr lang="zh-CN" sz="1400" b="0" dirty="0">
                 <a:solidFill>
                   <a:srgbClr val="CDCDD2"/>
                 </a:solidFill>
                 <a:latin typeface="Arial" pitchFamily="34" charset="0"/>
                 <a:ea typeface="Microsoft YaHei" pitchFamily="34" charset="-122"/>
               </a:rPr>
-              <a:t>V2V 车车直连 | V2P 车与弱势道路使用者 | V2I 车路协同 | 非视距穿透 · 恶劣天气抗扰 · 意图共享</a:t>
+              <a:t>基于C-NCAP 2027版管理规则原文 · 仅列出文档中明确提及V2X/C-V2X的测试场景</a:t>
             </a:r>
           </a:p>
         </p:txBody>
@@ -4669,7 +4669,7 @@
                 <a:latin typeface="Arial" pitchFamily="34" charset="0"/>
                 <a:ea typeface="Microsoft YaHei" pitchFamily="34" charset="-122"/>
               </a:rPr>
-              <a:t>附录P — VRU场景 | V2P / 车与弱势道路使用者</a:t>
+              <a:t>附录P — VRU保护 | V2X提及情况</a:t>
             </a:r>
           </a:p>
         </p:txBody>
@@ -4697,44 +4697,56 @@
               <a:buNone/>
             </a:pPr>
             <a:r>
-              <a:rPr lang="zh-CN" sz="900" b="1" dirty="0">
+              <a:rPr lang="zh-CN" sz="950" b="1" dirty="0">
                 <a:solidFill>
                   <a:srgbClr val="1EEF97"/>
                 </a:solidFill>
                 <a:latin typeface="Arial" pitchFamily="34" charset="0"/>
                 <a:ea typeface="Microsoft YaHei" pitchFamily="34" charset="-122"/>
               </a:rPr>
-              <a:t>V2P 穿透遮挡 — 行人/二轮车感知</a:t>
-            </a:r>
+              <a:t>附录P — VRU 弱势道路使用者保护</a:t>
+            </a:r>
+          </a:p>
+          <a:p>
+            <a:pPr marL="0" indent="0" algn="l">
+              <a:buNone/>
+            </a:pPr>
+            <a:endParaRPr lang="zh-CN" sz="300" dirty="0"/>
           </a:p>
           <a:p>
             <a:pPr marL="171450" indent="0" algn="l">
               <a:buNone/>
             </a:pPr>
             <a:r>
-              <a:rPr lang="zh-CN" sz="700" dirty="0">
+              <a:rPr lang="zh-CN" sz="800" dirty="0">
                 <a:solidFill>
                   <a:srgbClr val="CDCDD2"/>
                 </a:solidFill>
                 <a:latin typeface="Arial" pitchFamily="34" charset="0"/>
                 <a:ea typeface="Microsoft YaHei" pitchFamily="34" charset="-122"/>
               </a:rPr>
-              <a:t>CPFC-MO 动态遮挡儿童 — 被挡儿童可被V2P提前感知</a:t>
-            </a:r>
+              <a:t>结论：附录P中未明确提及 V2X / C-V2X 技术</a:t>
+            </a:r>
+          </a:p>
+          <a:p>
+            <a:pPr marL="0" indent="0" algn="l">
+              <a:buNone/>
+            </a:pPr>
+            <a:endParaRPr lang="zh-CN" sz="300" dirty="0"/>
           </a:p>
           <a:p>
             <a:pPr marL="171450" indent="0" algn="l">
               <a:buNone/>
             </a:pPr>
             <a:r>
-              <a:rPr lang="zh-CN" sz="700" dirty="0">
+              <a:rPr lang="zh-CN" sz="750" dirty="0">
                 <a:solidFill>
                   <a:srgbClr val="CDCDD2"/>
                 </a:solidFill>
                 <a:latin typeface="Arial" pitchFamily="34" charset="0"/>
                 <a:ea typeface="Microsoft YaHei" pitchFamily="34" charset="-122"/>
               </a:rPr>
-              <a:t>CPNC-AI / CPFC-BI 干扰横穿 — 被遮挡弱势道路使用者</a:t>
+              <a:t>附录P的31个VRU场景均基于车载传感器（摄像头、雷达、</a:t>
             </a:r>
           </a:p>
           <a:p>
@@ -4742,14 +4754,14 @@
               <a:buNone/>
             </a:pPr>
             <a:r>
-              <a:rPr lang="zh-CN" sz="700" dirty="0">
+              <a:rPr lang="zh-CN" sz="750" dirty="0">
                 <a:solidFill>
                   <a:srgbClr val="CDCDD2"/>
                 </a:solidFill>
                 <a:latin typeface="Arial" pitchFamily="34" charset="0"/>
                 <a:ea typeface="Microsoft YaHei" pitchFamily="34" charset="-122"/>
               </a:rPr>
-              <a:t>CBOFA / CBFA-MO 遮挡斜穿 — 穿透车辆障碍物</a:t>
+              <a:t>激光雷达）进行感知。V2P（车与行人/二轮车通信）尚未</a:t>
             </a:r>
           </a:p>
           <a:p>
@@ -4757,176 +4769,50 @@
               <a:buNone/>
             </a:pPr>
             <a:r>
-              <a:rPr lang="zh-CN" sz="700" dirty="0">
+              <a:rPr lang="zh-CN" sz="750" dirty="0">
                 <a:solidFill>
                   <a:srgbClr val="CDCDD2"/>
                 </a:solidFill>
                 <a:latin typeface="Arial" pitchFamily="34" charset="0"/>
                 <a:ea typeface="Microsoft YaHei" pitchFamily="34" charset="-122"/>
               </a:rPr>
-              <a:t>CBNA-AI / CSFA-BI 干扰近端 — V2P弥补传感器盲区</a:t>
-            </a:r>
+              <a:t>纳入C-NCAP 2027的VRU测试评价规程。</a:t>
+            </a:r>
+          </a:p>
+          <a:p>
+            <a:pPr marL="0" indent="0" algn="l">
+              <a:buNone/>
+            </a:pPr>
+            <a:endParaRPr lang="zh-CN" sz="300" dirty="0"/>
           </a:p>
           <a:p>
             <a:pPr marL="171450" indent="0" algn="l">
               <a:buNone/>
             </a:pPr>
             <a:r>
-              <a:rPr lang="zh-CN" sz="700" dirty="0">
+              <a:rPr lang="zh-CN" sz="750" dirty="0">
                 <a:solidFill>
                   <a:srgbClr val="CDCDD2"/>
                 </a:solidFill>
                 <a:latin typeface="Arial" pitchFamily="34" charset="0"/>
                 <a:ea typeface="Microsoft YaHei" pitchFamily="34" charset="-122"/>
               </a:rPr>
-              <a:t>CSTAO-RN 右转遮挡 — 路侧V2I+车端V2P协同</a:t>
-            </a:r>
-          </a:p>
-          <a:p>
-            <a:pPr marL="0" indent="0" algn="l">
-              <a:buNone/>
-            </a:pPr>
-            <a:endParaRPr lang="zh-CN" sz="300" dirty="0"/>
-          </a:p>
-          <a:p>
-            <a:pPr marL="0" indent="0" algn="l">
-              <a:buNone/>
-            </a:pPr>
-            <a:r>
-              <a:rPr lang="zh-CN" sz="900" b="1" dirty="0">
-                <a:solidFill>
-                  <a:srgbClr val="1EEF97"/>
+              <a:t>这意味着：当前VRU保护测试仅评估单车智能的感知能力，</a:t>
+            </a:r>
+          </a:p>
+          <a:p>
+            <a:pPr marL="171450" indent="0" algn="l">
+              <a:buNone/>
+            </a:pPr>
+            <a:r>
+              <a:rPr lang="zh-CN" sz="750" dirty="0">
+                <a:solidFill>
+                  <a:srgbClr val="CDCDD2"/>
                 </a:solidFill>
                 <a:latin typeface="Arial" pitchFamily="34" charset="0"/>
                 <a:ea typeface="Microsoft YaHei" pitchFamily="34" charset="-122"/>
               </a:rPr>
-              <a:t>V2P 转弯/横穿预警</a:t>
-            </a:r>
-          </a:p>
-          <a:p>
-            <a:pPr marL="171450" indent="0" algn="l">
-              <a:buNone/>
-            </a:pPr>
-            <a:r>
-              <a:rPr lang="zh-CN" sz="700" dirty="0">
-                <a:solidFill>
-                  <a:srgbClr val="CDCDD2"/>
-                </a:solidFill>
-                <a:latin typeface="Arial" pitchFamily="34" charset="0"/>
-                <a:ea typeface="Microsoft YaHei" pitchFamily="34" charset="-122"/>
-              </a:rPr>
-              <a:t>CPTA-LF / CPTA-RF 转弯横穿行人 — 提前感知意图</a:t>
-            </a:r>
-          </a:p>
-          <a:p>
-            <a:pPr marL="171450" indent="0" algn="l">
-              <a:buNone/>
-            </a:pPr>
-            <a:r>
-              <a:rPr lang="zh-CN" sz="700" dirty="0">
-                <a:solidFill>
-                  <a:srgbClr val="CDCDD2"/>
-                </a:solidFill>
-                <a:latin typeface="Arial" pitchFamily="34" charset="0"/>
-                <a:ea typeface="Microsoft YaHei" pitchFamily="34" charset="-122"/>
-              </a:rPr>
-              <a:t>C2S RCPf / C2B RCPn 转弯横穿二轮 — 路口盲区</a:t>
-            </a:r>
-          </a:p>
-          <a:p>
-            <a:pPr marL="171450" indent="0" algn="l">
-              <a:buNone/>
-            </a:pPr>
-            <a:r>
-              <a:rPr lang="zh-CN" sz="700" dirty="0">
-                <a:solidFill>
-                  <a:srgbClr val="CDCDD2"/>
-                </a:solidFill>
-                <a:latin typeface="Arial" pitchFamily="34" charset="0"/>
-                <a:ea typeface="Microsoft YaHei" pitchFamily="34" charset="-122"/>
-              </a:rPr>
-              <a:t>CBLAt 转弯切入 / CBLAc 变道切入 — 意图共享</a:t>
-            </a:r>
-          </a:p>
-          <a:p>
-            <a:pPr marL="171450" indent="0" algn="l">
-              <a:buNone/>
-            </a:pPr>
-            <a:r>
-              <a:rPr lang="zh-CN" sz="700" dirty="0">
-                <a:solidFill>
-                  <a:srgbClr val="CDCDD2"/>
-                </a:solidFill>
-                <a:latin typeface="Arial" pitchFamily="34" charset="0"/>
-                <a:ea typeface="Microsoft YaHei" pitchFamily="34" charset="-122"/>
-              </a:rPr>
-              <a:t>CSFhol 直行对向二轮 — 远距离V2P预警</a:t>
-            </a:r>
-          </a:p>
-          <a:p>
-            <a:pPr marL="0" indent="0" algn="l">
-              <a:buNone/>
-            </a:pPr>
-            <a:endParaRPr lang="zh-CN" sz="300" dirty="0"/>
-          </a:p>
-          <a:p>
-            <a:pPr marL="0" indent="0" algn="l">
-              <a:buNone/>
-            </a:pPr>
-            <a:r>
-              <a:rPr lang="zh-CN" sz="900" b="1" dirty="0">
-                <a:solidFill>
-                  <a:srgbClr val="CDCDD2"/>
-                </a:solidFill>
-                <a:latin typeface="Arial" pitchFamily="34" charset="0"/>
-                <a:ea typeface="Microsoft YaHei" pitchFamily="34" charset="-122"/>
-              </a:rPr>
-              <a:t>恶劣环境 — 天气/光照不敏感</a:t>
-            </a:r>
-          </a:p>
-          <a:p>
-            <a:pPr marL="171450" indent="0" algn="l">
-              <a:buNone/>
-            </a:pPr>
-            <a:r>
-              <a:rPr lang="zh-CN" sz="700" dirty="0">
-                <a:solidFill>
-                  <a:srgbClr val="CDCDD2"/>
-                </a:solidFill>
-                <a:latin typeface="Arial" pitchFamily="34" charset="0"/>
-                <a:ea typeface="Microsoft YaHei" pitchFamily="34" charset="-122"/>
-              </a:rPr>
-              <a:t>CPFAr 雨天远端横穿 — 摄像头受限，V2X不受影响</a:t>
-            </a:r>
-          </a:p>
-          <a:p>
-            <a:pPr marL="171450" indent="0" algn="l">
-              <a:buNone/>
-            </a:pPr>
-            <a:r>
-              <a:rPr lang="zh-CN" sz="700" dirty="0">
-                <a:solidFill>
-                  <a:srgbClr val="CDCDD2"/>
-                </a:solidFill>
-                <a:latin typeface="Arial" pitchFamily="34" charset="0"/>
-                <a:ea typeface="Microsoft YaHei" pitchFamily="34" charset="-122"/>
-              </a:rPr>
-              <a:t>CBLAb 电动自行车夜间 — 弱光下V2P优于视觉</a:t>
-            </a:r>
-          </a:p>
-          <a:p>
-            <a:pPr marL="171450" indent="0" algn="l">
-              <a:buNone/>
-            </a:pPr>
-            <a:r>
-              <a:rPr lang="zh-CN" sz="700" dirty="0">
-                <a:solidFill>
-                  <a:srgbClr val="CDCDD2"/>
-                </a:solidFill>
-                <a:latin typeface="Arial" pitchFamily="34" charset="0"/>
-                <a:ea typeface="Microsoft YaHei" pitchFamily="34" charset="-122"/>
-              </a:rPr>
-              <a:t>CPFAh / CPLAh 高速场景 — 远距离V2P提前预警</a:t>
+              <a:t>V2X在弱势道路使用者保护领域的标准化测试尚属空白。</a:t>
             </a:r>
           </a:p>
         </p:txBody>
@@ -4961,7 +4847,7 @@
                 <a:latin typeface="Arial" pitchFamily="34" charset="0"/>
                 <a:ea typeface="Microsoft YaHei" pitchFamily="34" charset="-122"/>
               </a:rPr>
-              <a:t>附录Q — C2C场景 | V2V / V2I 车车与车路协同</a:t>
+              <a:t>附录Q — C2C ADAS | 涉及 C-V2X 的场景（文档原文）</a:t>
             </a:r>
           </a:p>
         </p:txBody>
@@ -4989,21 +4875,42 @@
               <a:buNone/>
             </a:pPr>
             <a:r>
-              <a:rPr lang="zh-CN" sz="900" b="1" dirty="0">
+              <a:rPr lang="zh-CN" sz="950" b="1" dirty="0">
                 <a:solidFill>
                   <a:srgbClr val="1EEF97"/>
                 </a:solidFill>
                 <a:latin typeface="Arial" pitchFamily="34" charset="0"/>
                 <a:ea typeface="Microsoft YaHei" pitchFamily="34" charset="-122"/>
               </a:rPr>
-              <a:t>V2V 遮挡/非视距 — 穿透障碍感知</a:t>
-            </a:r>
+              <a:t>附录Q — C2C 车对车 ADAS · 涉及 V2X 的场景</a:t>
+            </a:r>
+          </a:p>
+          <a:p>
+            <a:pPr marL="0" indent="0" algn="l">
+              <a:buNone/>
+            </a:pPr>
+            <a:endParaRPr lang="zh-CN" sz="300" dirty="0"/>
           </a:p>
           <a:p>
             <a:pPr marL="171450" indent="0" algn="l">
               <a:buNone/>
             </a:pPr>
             <a:r>
+              <a:rPr lang="zh-CN" sz="850" b="1" dirty="0">
+                <a:solidFill>
+                  <a:srgbClr val="1EEF97"/>
+                </a:solidFill>
+                <a:latin typeface="Arial" pitchFamily="34" charset="0"/>
+                <a:ea typeface="Microsoft YaHei" pitchFamily="34" charset="-122"/>
+              </a:rPr>
+              <a:t>GVT 目标车 · 可具备 C-V2X 直连通信能力</a:t>
+            </a:r>
+          </a:p>
+          <a:p>
+            <a:pPr marL="171450" indent="0" algn="l">
+              <a:buNone/>
+            </a:pPr>
+            <a:r>
               <a:rPr lang="zh-CN" sz="700" dirty="0">
                 <a:solidFill>
                   <a:srgbClr val="CDCDD2"/>
@@ -5011,7 +4918,7 @@
                 <a:latin typeface="Arial" pitchFamily="34" charset="0"/>
                 <a:ea typeface="Microsoft YaHei" pitchFamily="34" charset="-122"/>
               </a:rPr>
-              <a:t>C2C SCPmo 动态遮挡横穿 — 被挡车辆V2V预警</a:t>
+              <a:t>附录Q规定GVT（全局车辆目标物）可集成C-V2X直连通信</a:t>
             </a:r>
           </a:p>
           <a:p>
@@ -5026,7 +4933,7 @@
                 <a:latin typeface="Arial" pitchFamily="34" charset="0"/>
                 <a:ea typeface="Microsoft YaHei" pitchFamily="34" charset="-122"/>
               </a:rPr>
-              <a:t>C2C SCPso 静态遮挡横穿 — 越过建筑物感知</a:t>
+              <a:t>模块，并具备第三方电子认证机构认可的互信能力。（见</a:t>
             </a:r>
           </a:p>
           <a:p>
@@ -5041,14 +4948,56 @@
                 <a:latin typeface="Arial" pitchFamily="34" charset="0"/>
                 <a:ea typeface="Microsoft YaHei" pitchFamily="34" charset="-122"/>
               </a:rPr>
-              <a:t>CCFT / CCFTf 转弯对撞 — 路口建筑遮挡，V2V直连</a:t>
-            </a:r>
+              <a:t>Q.3.6.1.2.4章节，第13/20/25页）</a:t>
+            </a:r>
+          </a:p>
+          <a:p>
+            <a:pPr marL="0" indent="0" algn="l">
+              <a:buNone/>
+            </a:pPr>
+            <a:endParaRPr lang="zh-CN" sz="300" dirty="0"/>
           </a:p>
           <a:p>
             <a:pPr marL="171450" indent="0" algn="l">
               <a:buNone/>
             </a:pPr>
             <a:r>
+              <a:rPr lang="zh-CN" sz="850" b="1" dirty="0">
+                <a:solidFill>
+                  <a:srgbClr val="1EEF97"/>
+                </a:solidFill>
+                <a:latin typeface="Arial" pitchFamily="34" charset="0"/>
+                <a:ea typeface="Microsoft YaHei" pitchFamily="34" charset="-122"/>
+              </a:rPr>
+              <a:t>当车辆具备 C-V2X 时，以下为必测场景：</a:t>
+            </a:r>
+          </a:p>
+          <a:p>
+            <a:pPr marL="0" indent="0" algn="l">
+              <a:buNone/>
+            </a:pPr>
+            <a:endParaRPr lang="zh-CN" sz="300" dirty="0"/>
+          </a:p>
+          <a:p>
+            <a:pPr marL="171450" indent="0" algn="l">
+              <a:buNone/>
+            </a:pPr>
+            <a:r>
+              <a:rPr lang="zh-CN" sz="800" b="1" dirty="0">
+                <a:solidFill>
+                  <a:srgbClr val="CDCDD2"/>
+                </a:solidFill>
+                <a:latin typeface="Arial" pitchFamily="34" charset="0"/>
+                <a:ea typeface="Microsoft YaHei" pitchFamily="34" charset="-122"/>
+              </a:rPr>
+              <a:t>① CCRh — 高速追尾</a:t>
+            </a:r>
+          </a:p>
+          <a:p>
+            <a:pPr marL="171450" indent="0" algn="l">
+              <a:buNone/>
+            </a:pPr>
+            <a:r>
               <a:rPr lang="zh-CN" sz="700" dirty="0">
                 <a:solidFill>
                   <a:srgbClr val="CDCDD2"/>
@@ -5056,7 +5005,22 @@
                 <a:latin typeface="Arial" pitchFamily="34" charset="0"/>
                 <a:ea typeface="Microsoft YaHei" pitchFamily="34" charset="-122"/>
               </a:rPr>
-              <a:t>LCPf / LCPn 左转横穿 — 对向遮挡车辆提前通信</a:t>
+              <a:t>远距离前车减速预警，V2V可增加感知距离，弥补传感器</a:t>
+            </a:r>
+          </a:p>
+          <a:p>
+            <a:pPr marL="171450" indent="0" algn="l">
+              <a:buNone/>
+            </a:pPr>
+            <a:r>
+              <a:rPr lang="zh-CN" sz="700" dirty="0">
+                <a:solidFill>
+                  <a:srgbClr val="CDCDD2"/>
+                </a:solidFill>
+                <a:latin typeface="Arial" pitchFamily="34" charset="0"/>
+                <a:ea typeface="Microsoft YaHei" pitchFamily="34" charset="-122"/>
+              </a:rPr>
+              <a:t>探测范围限制，实现超视距协同制动</a:t>
             </a:r>
           </a:p>
           <a:p>
@@ -5066,18 +5030,18 @@
             <a:endParaRPr lang="zh-CN" sz="300" dirty="0"/>
           </a:p>
           <a:p>
-            <a:pPr marL="0" indent="0" algn="l">
-              <a:buNone/>
-            </a:pPr>
-            <a:r>
-              <a:rPr lang="zh-CN" sz="900" b="1" dirty="0">
-                <a:solidFill>
-                  <a:srgbClr val="1EEF97"/>
+            <a:pPr marL="171450" indent="0" algn="l">
+              <a:buNone/>
+            </a:pPr>
+            <a:r>
+              <a:rPr lang="zh-CN" sz="800" b="1" dirty="0">
+                <a:solidFill>
+                  <a:srgbClr val="CDCDD2"/>
                 </a:solidFill>
                 <a:latin typeface="Arial" pitchFamily="34" charset="0"/>
                 <a:ea typeface="Microsoft YaHei" pitchFamily="34" charset="-122"/>
               </a:rPr>
-              <a:t>V2V 恶劣天气 — 传感器降级补偿</a:t>
+              <a:t>② CCFhos — 直行对撞</a:t>
             </a:r>
           </a:p>
           <a:p>
@@ -5092,7 +5056,7 @@
                 <a:latin typeface="Arial" pitchFamily="34" charset="0"/>
                 <a:ea typeface="Microsoft YaHei" pitchFamily="34" charset="-122"/>
               </a:rPr>
-              <a:t>CCRsr 雨天追尾 — 雷达/摄像头衰减，V2V不受影响</a:t>
+              <a:t>有遮挡的交叉路口对向碰撞场景，V2V穿透建筑物/车辆</a:t>
             </a:r>
           </a:p>
           <a:p>
@@ -5107,14 +5071,35 @@
                 <a:latin typeface="Arial" pitchFamily="34" charset="0"/>
                 <a:ea typeface="Microsoft YaHei" pitchFamily="34" charset="-122"/>
               </a:rPr>
-              <a:t>CCRsf 雾天追尾 — 能见度极低，V2V稳定通信</a:t>
-            </a:r>
+              <a:t>遮挡，提前获知对向来车位置与速度</a:t>
+            </a:r>
+          </a:p>
+          <a:p>
+            <a:pPr marL="0" indent="0" algn="l">
+              <a:buNone/>
+            </a:pPr>
+            <a:endParaRPr lang="zh-CN" sz="300" dirty="0"/>
           </a:p>
           <a:p>
             <a:pPr marL="171450" indent="0" algn="l">
               <a:buNone/>
             </a:pPr>
             <a:r>
+              <a:rPr lang="zh-CN" sz="800" b="1" dirty="0">
+                <a:solidFill>
+                  <a:srgbClr val="CDCDD2"/>
+                </a:solidFill>
+                <a:latin typeface="Arial" pitchFamily="34" charset="0"/>
+                <a:ea typeface="Microsoft YaHei" pitchFamily="34" charset="-122"/>
+              </a:rPr>
+              <a:t>③ C2C SCPso — 静态遮挡横穿</a:t>
+            </a:r>
+          </a:p>
+          <a:p>
+            <a:pPr marL="171450" indent="0" algn="l">
+              <a:buNone/>
+            </a:pPr>
+            <a:r>
               <a:rPr lang="zh-CN" sz="700" dirty="0">
                 <a:solidFill>
                   <a:srgbClr val="CDCDD2"/>
@@ -5122,7 +5107,22 @@
                 <a:latin typeface="Arial" pitchFamily="34" charset="0"/>
                 <a:ea typeface="Microsoft YaHei" pitchFamily="34" charset="-122"/>
               </a:rPr>
-              <a:t>CCFhos 直行对撞 — 雨雾天远距离V2V预警</a:t>
+              <a:t>目标车被路边停放车辆遮挡后横穿，V2V可越过静态障碍</a:t>
+            </a:r>
+          </a:p>
+          <a:p>
+            <a:pPr marL="171450" indent="0" algn="l">
+              <a:buNone/>
+            </a:pPr>
+            <a:r>
+              <a:rPr lang="zh-CN" sz="700" dirty="0">
+                <a:solidFill>
+                  <a:srgbClr val="CDCDD2"/>
+                </a:solidFill>
+                <a:latin typeface="Arial" pitchFamily="34" charset="0"/>
+                <a:ea typeface="Microsoft YaHei" pitchFamily="34" charset="-122"/>
+              </a:rPr>
+              <a:t>感知被遮挡移动车辆，解决非视距（NLOS）问题</a:t>
             </a:r>
           </a:p>
           <a:p>
@@ -5132,144 +5132,18 @@
             <a:endParaRPr lang="zh-CN" sz="300" dirty="0"/>
           </a:p>
           <a:p>
-            <a:pPr marL="0" indent="0" algn="l">
-              <a:buNone/>
-            </a:pPr>
-            <a:r>
-              <a:rPr lang="zh-CN" sz="900" b="1" dirty="0">
+            <a:pPr marL="171450" indent="0" algn="l">
+              <a:buNone/>
+            </a:pPr>
+            <a:r>
+              <a:rPr lang="zh-CN" sz="700" dirty="0">
                 <a:solidFill>
                   <a:srgbClr val="CDCDD2"/>
                 </a:solidFill>
                 <a:latin typeface="Arial" pitchFamily="34" charset="0"/>
                 <a:ea typeface="Microsoft YaHei" pitchFamily="34" charset="-122"/>
               </a:rPr>
-              <a:t>V2V 意图共享 — 切入/制动预警</a:t>
-            </a:r>
-          </a:p>
-          <a:p>
-            <a:pPr marL="171450" indent="0" algn="l">
-              <a:buNone/>
-            </a:pPr>
-            <a:r>
-              <a:rPr lang="zh-CN" sz="700" dirty="0">
-                <a:solidFill>
-                  <a:srgbClr val="CDCDD2"/>
-                </a:solidFill>
-                <a:latin typeface="Arial" pitchFamily="34" charset="0"/>
-                <a:ea typeface="Microsoft YaHei" pitchFamily="34" charset="-122"/>
-              </a:rPr>
-              <a:t>CCRc 切入追尾 — 邻车变道意图实时共享</a:t>
-            </a:r>
-          </a:p>
-          <a:p>
-            <a:pPr marL="171450" indent="0" algn="l">
-              <a:buNone/>
-            </a:pPr>
-            <a:r>
-              <a:rPr lang="zh-CN" sz="700" dirty="0">
-                <a:solidFill>
-                  <a:srgbClr val="CDCDD2"/>
-                </a:solidFill>
-                <a:latin typeface="Arial" pitchFamily="34" charset="0"/>
-                <a:ea typeface="Microsoft YaHei" pitchFamily="34" charset="-122"/>
-              </a:rPr>
-              <a:t>CCRb 制动追尾 — 前车制动信号低延迟广播</a:t>
-            </a:r>
-          </a:p>
-          <a:p>
-            <a:pPr marL="171450" indent="0" algn="l">
-              <a:buNone/>
-            </a:pPr>
-            <a:r>
-              <a:rPr lang="zh-CN" sz="700" dirty="0">
-                <a:solidFill>
-                  <a:srgbClr val="CDCDD2"/>
-                </a:solidFill>
-                <a:latin typeface="Arial" pitchFamily="34" charset="0"/>
-                <a:ea typeface="Microsoft YaHei" pitchFamily="34" charset="-122"/>
-              </a:rPr>
-              <a:t>CCRh 高速追尾 / CCRbc 弯道制动 — 超视距补盲</a:t>
-            </a:r>
-          </a:p>
-          <a:p>
-            <a:pPr marL="171450" indent="0" algn="l">
-              <a:buNone/>
-            </a:pPr>
-            <a:r>
-              <a:rPr lang="zh-CN" sz="700" dirty="0">
-                <a:solidFill>
-                  <a:srgbClr val="CDCDD2"/>
-                </a:solidFill>
-                <a:latin typeface="Arial" pitchFamily="34" charset="0"/>
-                <a:ea typeface="Microsoft YaHei" pitchFamily="34" charset="-122"/>
-              </a:rPr>
-              <a:t>RCPf 右转横穿 — 转向意图+位置共享</a:t>
-            </a:r>
-          </a:p>
-          <a:p>
-            <a:pPr marL="0" indent="0" algn="l">
-              <a:buNone/>
-            </a:pPr>
-            <a:endParaRPr lang="zh-CN" sz="300" dirty="0"/>
-          </a:p>
-          <a:p>
-            <a:pPr marL="0" indent="0" algn="l">
-              <a:buNone/>
-            </a:pPr>
-            <a:r>
-              <a:rPr lang="zh-CN" sz="900" b="1" dirty="0">
-                <a:solidFill>
-                  <a:srgbClr val="CDCDD2"/>
-                </a:solidFill>
-                <a:latin typeface="Arial" pitchFamily="34" charset="0"/>
-                <a:ea typeface="Microsoft YaHei" pitchFamily="34" charset="-122"/>
-              </a:rPr>
-              <a:t>V2I 路侧协同</a:t>
-            </a:r>
-          </a:p>
-          <a:p>
-            <a:pPr marL="171450" indent="0" algn="l">
-              <a:buNone/>
-            </a:pPr>
-            <a:r>
-              <a:rPr lang="zh-CN" sz="700" dirty="0">
-                <a:solidFill>
-                  <a:srgbClr val="CDCDD2"/>
-                </a:solidFill>
-                <a:latin typeface="Arial" pitchFamily="34" charset="0"/>
-                <a:ea typeface="Microsoft YaHei" pitchFamily="34" charset="-122"/>
-              </a:rPr>
-              <a:t>全部路口转弯/横穿场景可通过V2I路侧单元(RSU)</a:t>
-            </a:r>
-          </a:p>
-          <a:p>
-            <a:pPr marL="171450" indent="0" algn="l">
-              <a:buNone/>
-            </a:pPr>
-            <a:r>
-              <a:rPr lang="zh-CN" sz="700" dirty="0">
-                <a:solidFill>
-                  <a:srgbClr val="CDCDD2"/>
-                </a:solidFill>
-                <a:latin typeface="Arial" pitchFamily="34" charset="0"/>
-                <a:ea typeface="Microsoft YaHei" pitchFamily="34" charset="-122"/>
-              </a:rPr>
-              <a:t>获取路口全局目标列表，弥补单车感知盲区</a:t>
-            </a:r>
-          </a:p>
-          <a:p>
-            <a:pPr marL="171450" indent="0" algn="l">
-              <a:buNone/>
-            </a:pPr>
-            <a:r>
-              <a:rPr lang="zh-CN" sz="700" dirty="0">
-                <a:solidFill>
-                  <a:srgbClr val="CDCDD2"/>
-                </a:solidFill>
-                <a:latin typeface="Arial" pitchFamily="34" charset="0"/>
-                <a:ea typeface="Microsoft YaHei" pitchFamily="34" charset="-122"/>
-              </a:rPr>
-              <a:t>典型: CPTA系列 / CCFT系列 / C2C LCP&amp;SCP系列</a:t>
+              <a:t>上述场景不参与排序抽取，直接列为必测（Q.3.6.1.7.11.5）</a:t>
             </a:r>
           </a:p>
         </p:txBody>
@@ -5317,14 +5191,14 @@
               <a:buNone/>
             </a:pPr>
             <a:r>
-              <a:rPr lang="en-US" sz="1600" b="1" dirty="0">
+              <a:rPr lang="zh-CN" sz="1600" b="1" dirty="0">
                 <a:solidFill>
                   <a:srgbClr val="1EEF97"/>
                 </a:solidFill>
                 <a:latin typeface="Arial" pitchFamily="34" charset="0"/>
                 <a:ea typeface="Microsoft YaHei" pitchFamily="34" charset="-122"/>
               </a:rPr>
-              <a:t>~70%</a:t>
+              <a:t>3</a:t>
             </a:r>
           </a:p>
         </p:txBody>
@@ -5352,14 +5226,14 @@
               <a:buNone/>
             </a:pPr>
             <a:r>
-              <a:rPr lang="zh-CN" sz="800" dirty="0">
+              <a:rPr lang="zh-CN" sz="800" b="0" dirty="0">
                 <a:solidFill>
                   <a:srgbClr val="CDCDD2"/>
                 </a:solidFill>
                 <a:latin typeface="Arial" pitchFamily="34" charset="0"/>
                 <a:ea typeface="Microsoft YaHei" pitchFamily="34" charset="-122"/>
               </a:rPr>
-              <a:t>场景可由V2X增强</a:t>
+              <a:t>V2X必测场景数</a:t>
             </a:r>
           </a:p>
         </p:txBody>
@@ -5387,14 +5261,14 @@
               <a:buNone/>
             </a:pPr>
             <a:r>
-              <a:rPr lang="en-US" sz="1600" b="1" dirty="0">
+              <a:rPr lang="zh-CN" sz="1600" b="1" dirty="0">
                 <a:solidFill>
                   <a:srgbClr val="1EEF97"/>
                 </a:solidFill>
                 <a:latin typeface="Arial" pitchFamily="34" charset="0"/>
                 <a:ea typeface="Microsoft YaHei" pitchFamily="34" charset="-122"/>
               </a:rPr>
-              <a:t>V2V+P+I</a:t>
+              <a:t>GVT</a:t>
             </a:r>
           </a:p>
         </p:txBody>
@@ -5422,14 +5296,14 @@
               <a:buNone/>
             </a:pPr>
             <a:r>
-              <a:rPr lang="zh-CN" sz="800" dirty="0">
+              <a:rPr lang="zh-CN" sz="800" b="0" dirty="0">
                 <a:solidFill>
                   <a:srgbClr val="CDCDD2"/>
                 </a:solidFill>
                 <a:latin typeface="Arial" pitchFamily="34" charset="0"/>
                 <a:ea typeface="Microsoft YaHei" pitchFamily="34" charset="-122"/>
               </a:rPr>
-              <a:t>V2X通信模式协同</a:t>
+              <a:t>目标物支持C-V2X</a:t>
             </a:r>
           </a:p>
         </p:txBody>
@@ -5457,7 +5331,7 @@
               <a:buNone/>
             </a:pPr>
             <a:r>
-              <a:rPr lang="en-US" sz="1600" b="1" dirty="0">
+              <a:rPr lang="zh-CN" sz="1600" b="1" dirty="0">
                 <a:solidFill>
                   <a:srgbClr val="1EEF97"/>
                 </a:solidFill>
@@ -5492,14 +5366,14 @@
               <a:buNone/>
             </a:pPr>
             <a:r>
-              <a:rPr lang="zh-CN" sz="800" dirty="0">
+              <a:rPr lang="zh-CN" sz="800" b="0" dirty="0">
                 <a:solidFill>
                   <a:srgbClr val="CDCDD2"/>
                 </a:solidFill>
                 <a:latin typeface="Arial" pitchFamily="34" charset="0"/>
                 <a:ea typeface="Microsoft YaHei" pitchFamily="34" charset="-122"/>
               </a:rPr>
-              <a:t>非视距穿透是核心优势</a:t>
+              <a:t>核心解决场景</a:t>
             </a:r>
           </a:p>
         </p:txBody>
@@ -5527,14 +5401,14 @@
               <a:buNone/>
             </a:pPr>
             <a:r>
-              <a:rPr lang="en-US" sz="1600" b="1" dirty="0">
+              <a:rPr lang="zh-CN" sz="1600" b="1" dirty="0">
                 <a:solidFill>
                   <a:srgbClr val="1EEF97"/>
                 </a:solidFill>
                 <a:latin typeface="Arial" pitchFamily="34" charset="0"/>
                 <a:ea typeface="Microsoft YaHei" pitchFamily="34" charset="-122"/>
               </a:rPr>
-              <a:t>全天候</a:t>
+              <a:t>附录Q</a:t>
             </a:r>
           </a:p>
         </p:txBody>
@@ -5562,14 +5436,14 @@
               <a:buNone/>
             </a:pPr>
             <a:r>
-              <a:rPr lang="zh-CN" sz="800" dirty="0">
+              <a:rPr lang="zh-CN" sz="800" b="0" dirty="0">
                 <a:solidFill>
                   <a:srgbClr val="CDCDD2"/>
                 </a:solidFill>
                 <a:latin typeface="Arial" pitchFamily="34" charset="0"/>
                 <a:ea typeface="Microsoft YaHei" pitchFamily="34" charset="-122"/>
               </a:rPr>
-              <a:t>雨雾夜不受影响</a:t>
+              <a:t>V2X仅出现在附录Q</a:t>
             </a:r>
           </a:p>
         </p:txBody>
@@ -5597,14 +5471,14 @@
               <a:buNone/>
             </a:pPr>
             <a:r>
-              <a:rPr lang="zh-CN" sz="700" dirty="0">
+              <a:rPr lang="zh-CN" sz="700" b="0" dirty="0">
                 <a:solidFill>
                   <a:srgbClr val="888888"/>
                 </a:solidFill>
                 <a:latin typeface="Arial" pitchFamily="34" charset="0"/>
                 <a:ea typeface="Microsoft YaHei" pitchFamily="34" charset="-122"/>
               </a:rPr>
-              <a:t>INTERNAL / CONFIDENTIAL  |  CSD class: 2.5  |  基于 C-NCAP 2027 场景的 V2X 赋能分析</a:t>
+              <a:t>INTERNAL / CONFIDENTIAL  |  CSD class: 2.5  |  Source: C-NCAP 2027 附录Q (Q.3.6.1.2.4 / Q.3.6.1.7.11.5)</a:t>
             </a:r>
           </a:p>
         </p:txBody>

</xml_diff>